<commit_message>
Database setup completed and backend structure established. Health ceckpoint as well as database is reachable currently
</commit_message>
<xml_diff>
--- a/documentation/Frontend mockup.pptx
+++ b/documentation/Frontend mockup.pptx
@@ -10,7 +10,7 @@
     <p:sldId id="258" r:id="rId4"/>
     <p:sldId id="261" r:id="rId5"/>
     <p:sldId id="262" r:id="rId6"/>
-    <p:sldId id="263" r:id="rId7"/>
+    <p:sldId id="264" r:id="rId7"/>
   </p:sldIdLst>
   <p:sldSz cx="12192000" cy="6858000"/>
   <p:notesSz cx="6858000" cy="9144000"/>
@@ -29257,7 +29257,7 @@
         <p:cNvPr id="1" name="">
           <a:extLst>
             <a:ext uri="{FF2B5EF4-FFF2-40B4-BE49-F238E27FC236}">
-              <a16:creationId xmlns:a16="http://schemas.microsoft.com/office/drawing/2014/main" id="{E696C0B3-B114-88DA-80BE-CE1400A61E68}"/>
+              <a16:creationId xmlns:a16="http://schemas.microsoft.com/office/drawing/2014/main" id="{8B264774-508D-7ED1-6102-03AC0AC95E85}"/>
             </a:ext>
           </a:extLst>
         </p:cNvPr>
@@ -29274,10 +29274,10 @@
       </p:grpSpPr>
       <p:grpSp>
         <p:nvGrpSpPr>
-          <p:cNvPr id="43" name="Group 42">
+          <p:cNvPr id="2" name="Group 1">
             <a:extLst>
               <a:ext uri="{FF2B5EF4-FFF2-40B4-BE49-F238E27FC236}">
-                <a16:creationId xmlns:a16="http://schemas.microsoft.com/office/drawing/2014/main" id="{FFA3822B-6A68-4F19-9290-CA9B3C64E56B}"/>
+                <a16:creationId xmlns:a16="http://schemas.microsoft.com/office/drawing/2014/main" id="{9311031D-BD70-AD6D-14A6-8962C7D8FFA3}"/>
               </a:ext>
             </a:extLst>
           </p:cNvPr>
@@ -29294,10 +29294,10 @@
         </p:grpSpPr>
         <p:grpSp>
           <p:nvGrpSpPr>
-            <p:cNvPr id="44" name="Group 43">
+            <p:cNvPr id="3" name="Group 2">
               <a:extLst>
                 <a:ext uri="{FF2B5EF4-FFF2-40B4-BE49-F238E27FC236}">
-                  <a16:creationId xmlns:a16="http://schemas.microsoft.com/office/drawing/2014/main" id="{5069550D-23BF-EB2B-476D-5D54C08EB287}"/>
+                  <a16:creationId xmlns:a16="http://schemas.microsoft.com/office/drawing/2014/main" id="{4493FA8D-4D89-020A-9653-B5955C3D676E}"/>
                 </a:ext>
               </a:extLst>
             </p:cNvPr>
@@ -29314,10 +29314,10 @@
           </p:grpSpPr>
           <p:sp>
             <p:nvSpPr>
-              <p:cNvPr id="48" name="Rectangle 47">
+              <p:cNvPr id="7" name="Rectangle 6">
                 <a:extLst>
                   <a:ext uri="{FF2B5EF4-FFF2-40B4-BE49-F238E27FC236}">
-                    <a16:creationId xmlns:a16="http://schemas.microsoft.com/office/drawing/2014/main" id="{FD7AA267-CC37-D50E-56E4-0CE685559939}"/>
+                    <a16:creationId xmlns:a16="http://schemas.microsoft.com/office/drawing/2014/main" id="{47697464-5946-4121-C452-9B5B816F5D3E}"/>
                   </a:ext>
                 </a:extLst>
               </p:cNvPr>
@@ -29360,10 +29360,10 @@
           </p:sp>
           <p:sp>
             <p:nvSpPr>
-              <p:cNvPr id="49" name="Rectangle 48">
+              <p:cNvPr id="8" name="Rectangle 7">
                 <a:extLst>
                   <a:ext uri="{FF2B5EF4-FFF2-40B4-BE49-F238E27FC236}">
-                    <a16:creationId xmlns:a16="http://schemas.microsoft.com/office/drawing/2014/main" id="{EC081DFE-C325-A429-5C01-9689E8E13B3C}"/>
+                    <a16:creationId xmlns:a16="http://schemas.microsoft.com/office/drawing/2014/main" id="{5822908C-9474-E0B0-BBAC-C6EB693733B8}"/>
                   </a:ext>
                 </a:extLst>
               </p:cNvPr>
@@ -29412,10 +29412,10 @@
           </p:sp>
           <p:sp>
             <p:nvSpPr>
-              <p:cNvPr id="50" name="Rectangle 49">
+              <p:cNvPr id="9" name="Rectangle 8">
                 <a:extLst>
                   <a:ext uri="{FF2B5EF4-FFF2-40B4-BE49-F238E27FC236}">
-                    <a16:creationId xmlns:a16="http://schemas.microsoft.com/office/drawing/2014/main" id="{38B0F8DD-AFF0-D93D-BB23-F024A824DAA8}"/>
+                    <a16:creationId xmlns:a16="http://schemas.microsoft.com/office/drawing/2014/main" id="{D910D1D9-B60C-8B7B-B1E1-F60F1352D8EA}"/>
                   </a:ext>
                 </a:extLst>
               </p:cNvPr>
@@ -29464,10 +29464,10 @@
         </p:grpSp>
         <p:sp>
           <p:nvSpPr>
-            <p:cNvPr id="45" name="Rectangle: Rounded Corners 44">
+            <p:cNvPr id="4" name="Rectangle: Rounded Corners 3">
               <a:extLst>
                 <a:ext uri="{FF2B5EF4-FFF2-40B4-BE49-F238E27FC236}">
-                  <a16:creationId xmlns:a16="http://schemas.microsoft.com/office/drawing/2014/main" id="{2DA513C4-60C6-9B7F-7F4A-60DAF29AE452}"/>
+                  <a16:creationId xmlns:a16="http://schemas.microsoft.com/office/drawing/2014/main" id="{BAD8EC7E-B54C-03F7-3BB4-B9EA09280D0E}"/>
                 </a:ext>
               </a:extLst>
             </p:cNvPr>
@@ -29514,10 +29514,10 @@
         </p:sp>
         <p:sp>
           <p:nvSpPr>
-            <p:cNvPr id="46" name="Oval 45">
+            <p:cNvPr id="5" name="Oval 4">
               <a:extLst>
                 <a:ext uri="{FF2B5EF4-FFF2-40B4-BE49-F238E27FC236}">
-                  <a16:creationId xmlns:a16="http://schemas.microsoft.com/office/drawing/2014/main" id="{ED2FB1CA-07E2-5BD5-67F4-438B917B064E}"/>
+                  <a16:creationId xmlns:a16="http://schemas.microsoft.com/office/drawing/2014/main" id="{6DE0AA9E-7F3F-9093-FAED-D2A1FA75FC3C}"/>
                 </a:ext>
               </a:extLst>
             </p:cNvPr>
@@ -29560,10 +29560,10 @@
         </p:sp>
         <p:pic>
           <p:nvPicPr>
-            <p:cNvPr id="47" name="Picture 2" descr="Logo">
+            <p:cNvPr id="6" name="Picture 2" descr="Logo">
               <a:extLst>
                 <a:ext uri="{FF2B5EF4-FFF2-40B4-BE49-F238E27FC236}">
-                  <a16:creationId xmlns:a16="http://schemas.microsoft.com/office/drawing/2014/main" id="{332A78E2-35AF-CB90-FBCA-CE32194278A7}"/>
+                  <a16:creationId xmlns:a16="http://schemas.microsoft.com/office/drawing/2014/main" id="{CD3BF54B-6326-3CB8-3323-33CA2B1CAD09}"/>
                 </a:ext>
               </a:extLst>
             </p:cNvPr>
@@ -29608,10 +29608,10 @@
       </p:grpSp>
       <p:graphicFrame>
         <p:nvGraphicFramePr>
-          <p:cNvPr id="38" name="Table 37">
+          <p:cNvPr id="10" name="Table 9">
             <a:extLst>
               <a:ext uri="{FF2B5EF4-FFF2-40B4-BE49-F238E27FC236}">
-                <a16:creationId xmlns:a16="http://schemas.microsoft.com/office/drawing/2014/main" id="{3E68AFDC-15C1-52CC-8831-421D5F1CCFB2}"/>
+                <a16:creationId xmlns:a16="http://schemas.microsoft.com/office/drawing/2014/main" id="{80D7A4BF-933C-E388-4D77-6E209D58D3FE}"/>
               </a:ext>
             </a:extLst>
           </p:cNvPr>
@@ -29621,13 +29621,13 @@
           <p:nvPr>
             <p:extLst>
               <p:ext uri="{D42A27DB-BD31-4B8C-83A1-F6EECF244321}">
-                <p14:modId xmlns:p14="http://schemas.microsoft.com/office/powerpoint/2010/main" val="901263082"/>
+                <p14:modId xmlns:p14="http://schemas.microsoft.com/office/powerpoint/2010/main" val="4238794989"/>
               </p:ext>
             </p:extLst>
           </p:nvPr>
         </p:nvGraphicFramePr>
         <p:xfrm>
-          <a:off x="106096" y="452338"/>
+          <a:off x="105509" y="451046"/>
           <a:ext cx="2409090" cy="1463040"/>
         </p:xfrm>
         <a:graphic>
@@ -29942,10 +29942,2145 @@
           </a:graphicData>
         </a:graphic>
       </p:graphicFrame>
+      <p:sp>
+        <p:nvSpPr>
+          <p:cNvPr id="18" name="Rectangle: Rounded Corners 17">
+            <a:extLst>
+              <a:ext uri="{FF2B5EF4-FFF2-40B4-BE49-F238E27FC236}">
+                <a16:creationId xmlns:a16="http://schemas.microsoft.com/office/drawing/2014/main" id="{A45079E6-FE55-D184-7811-D91C2B172D38}"/>
+              </a:ext>
+            </a:extLst>
+          </p:cNvPr>
+          <p:cNvSpPr/>
+          <p:nvPr/>
+        </p:nvSpPr>
+        <p:spPr>
+          <a:xfrm>
+            <a:off x="8915401" y="2204232"/>
+            <a:ext cx="3033346" cy="4202722"/>
+          </a:xfrm>
+          <a:prstGeom prst="roundRect">
+            <a:avLst/>
+          </a:prstGeom>
+        </p:spPr>
+        <p:style>
+          <a:lnRef idx="2">
+            <a:schemeClr val="accent1">
+              <a:shade val="15000"/>
+            </a:schemeClr>
+          </a:lnRef>
+          <a:fillRef idx="1">
+            <a:schemeClr val="accent1"/>
+          </a:fillRef>
+          <a:effectRef idx="0">
+            <a:schemeClr val="accent1"/>
+          </a:effectRef>
+          <a:fontRef idx="minor">
+            <a:schemeClr val="lt1"/>
+          </a:fontRef>
+        </p:style>
+        <p:txBody>
+          <a:bodyPr rtlCol="0" anchor="ctr"/>
+          <a:lstStyle/>
+          <a:p>
+            <a:pPr algn="ctr"/>
+            <a:endParaRPr lang="en-IN"/>
+          </a:p>
+        </p:txBody>
+      </p:sp>
+      <p:sp>
+        <p:nvSpPr>
+          <p:cNvPr id="19" name="Rectangle: Rounded Corners 18">
+            <a:extLst>
+              <a:ext uri="{FF2B5EF4-FFF2-40B4-BE49-F238E27FC236}">
+                <a16:creationId xmlns:a16="http://schemas.microsoft.com/office/drawing/2014/main" id="{94FF22C4-A85E-2235-9520-22C57759C6DE}"/>
+              </a:ext>
+            </a:extLst>
+          </p:cNvPr>
+          <p:cNvSpPr/>
+          <p:nvPr/>
+        </p:nvSpPr>
+        <p:spPr>
+          <a:xfrm>
+            <a:off x="8952034" y="593481"/>
+            <a:ext cx="2664070" cy="1178169"/>
+          </a:xfrm>
+          <a:prstGeom prst="roundRect">
+            <a:avLst/>
+          </a:prstGeom>
+        </p:spPr>
+        <p:style>
+          <a:lnRef idx="2">
+            <a:schemeClr val="accent1">
+              <a:shade val="15000"/>
+            </a:schemeClr>
+          </a:lnRef>
+          <a:fillRef idx="1">
+            <a:schemeClr val="accent1"/>
+          </a:fillRef>
+          <a:effectRef idx="0">
+            <a:schemeClr val="accent1"/>
+          </a:effectRef>
+          <a:fontRef idx="minor">
+            <a:schemeClr val="lt1"/>
+          </a:fontRef>
+        </p:style>
+        <p:txBody>
+          <a:bodyPr rtlCol="0" anchor="ctr"/>
+          <a:lstStyle/>
+          <a:p>
+            <a:pPr algn="ctr"/>
+            <a:endParaRPr lang="en-IN"/>
+          </a:p>
+        </p:txBody>
+      </p:sp>
+      <p:sp>
+        <p:nvSpPr>
+          <p:cNvPr id="20" name="Rectangle: Rounded Corners 19">
+            <a:extLst>
+              <a:ext uri="{FF2B5EF4-FFF2-40B4-BE49-F238E27FC236}">
+                <a16:creationId xmlns:a16="http://schemas.microsoft.com/office/drawing/2014/main" id="{72931609-DBF7-005C-BF35-2CBF1D134024}"/>
+              </a:ext>
+            </a:extLst>
+          </p:cNvPr>
+          <p:cNvSpPr/>
+          <p:nvPr/>
+        </p:nvSpPr>
+        <p:spPr>
+          <a:xfrm>
+            <a:off x="6079880" y="593481"/>
+            <a:ext cx="2664070" cy="1178169"/>
+          </a:xfrm>
+          <a:prstGeom prst="roundRect">
+            <a:avLst/>
+          </a:prstGeom>
+        </p:spPr>
+        <p:style>
+          <a:lnRef idx="2">
+            <a:schemeClr val="accent1">
+              <a:shade val="15000"/>
+            </a:schemeClr>
+          </a:lnRef>
+          <a:fillRef idx="1">
+            <a:schemeClr val="accent1"/>
+          </a:fillRef>
+          <a:effectRef idx="0">
+            <a:schemeClr val="accent1"/>
+          </a:effectRef>
+          <a:fontRef idx="minor">
+            <a:schemeClr val="lt1"/>
+          </a:fontRef>
+        </p:style>
+        <p:txBody>
+          <a:bodyPr rtlCol="0" anchor="ctr"/>
+          <a:lstStyle/>
+          <a:p>
+            <a:pPr algn="ctr"/>
+            <a:endParaRPr lang="en-IN"/>
+          </a:p>
+        </p:txBody>
+      </p:sp>
+      <p:sp>
+        <p:nvSpPr>
+          <p:cNvPr id="21" name="Rectangle: Rounded Corners 20">
+            <a:extLst>
+              <a:ext uri="{FF2B5EF4-FFF2-40B4-BE49-F238E27FC236}">
+                <a16:creationId xmlns:a16="http://schemas.microsoft.com/office/drawing/2014/main" id="{5B3BB773-7689-FBAA-EFCD-9C170B695B31}"/>
+              </a:ext>
+            </a:extLst>
+          </p:cNvPr>
+          <p:cNvSpPr/>
+          <p:nvPr/>
+        </p:nvSpPr>
+        <p:spPr>
+          <a:xfrm>
+            <a:off x="3207726" y="593481"/>
+            <a:ext cx="2664070" cy="1178169"/>
+          </a:xfrm>
+          <a:prstGeom prst="roundRect">
+            <a:avLst/>
+          </a:prstGeom>
+        </p:spPr>
+        <p:style>
+          <a:lnRef idx="2">
+            <a:schemeClr val="accent1">
+              <a:shade val="15000"/>
+            </a:schemeClr>
+          </a:lnRef>
+          <a:fillRef idx="1">
+            <a:schemeClr val="accent1"/>
+          </a:fillRef>
+          <a:effectRef idx="0">
+            <a:schemeClr val="accent1"/>
+          </a:effectRef>
+          <a:fontRef idx="minor">
+            <a:schemeClr val="lt1"/>
+          </a:fontRef>
+        </p:style>
+        <p:txBody>
+          <a:bodyPr rtlCol="0" anchor="ctr"/>
+          <a:lstStyle/>
+          <a:p>
+            <a:pPr algn="ctr"/>
+            <a:endParaRPr lang="en-IN"/>
+          </a:p>
+        </p:txBody>
+      </p:sp>
+      <p:graphicFrame>
+        <p:nvGraphicFramePr>
+          <p:cNvPr id="24" name="Table 23">
+            <a:extLst>
+              <a:ext uri="{FF2B5EF4-FFF2-40B4-BE49-F238E27FC236}">
+                <a16:creationId xmlns:a16="http://schemas.microsoft.com/office/drawing/2014/main" id="{FAB34855-CC85-E1F9-D03D-1328CBBA8744}"/>
+              </a:ext>
+            </a:extLst>
+          </p:cNvPr>
+          <p:cNvGraphicFramePr>
+            <a:graphicFrameLocks noGrp="1"/>
+          </p:cNvGraphicFramePr>
+          <p:nvPr>
+            <p:extLst>
+              <p:ext uri="{D42A27DB-BD31-4B8C-83A1-F6EECF244321}">
+                <p14:modId xmlns:p14="http://schemas.microsoft.com/office/powerpoint/2010/main" val="2926930378"/>
+              </p:ext>
+            </p:extLst>
+          </p:nvPr>
+        </p:nvGraphicFramePr>
+        <p:xfrm>
+          <a:off x="3207726" y="2204232"/>
+          <a:ext cx="5536224" cy="3337560"/>
+        </p:xfrm>
+        <a:graphic>
+          <a:graphicData uri="http://schemas.openxmlformats.org/drawingml/2006/table">
+            <a:tbl>
+              <a:tblPr firstRow="1" bandRow="1">
+                <a:tableStyleId>{2D5ABB26-0587-4C30-8999-92F81FD0307C}</a:tableStyleId>
+              </a:tblPr>
+              <a:tblGrid>
+                <a:gridCol w="1384056">
+                  <a:extLst>
+                    <a:ext uri="{9D8B030D-6E8A-4147-A177-3AD203B41FA5}">
+                      <a16:colId xmlns:a16="http://schemas.microsoft.com/office/drawing/2014/main" val="519203008"/>
+                    </a:ext>
+                  </a:extLst>
+                </a:gridCol>
+                <a:gridCol w="1384056">
+                  <a:extLst>
+                    <a:ext uri="{9D8B030D-6E8A-4147-A177-3AD203B41FA5}">
+                      <a16:colId xmlns:a16="http://schemas.microsoft.com/office/drawing/2014/main" val="2182870733"/>
+                    </a:ext>
+                  </a:extLst>
+                </a:gridCol>
+                <a:gridCol w="1384056">
+                  <a:extLst>
+                    <a:ext uri="{9D8B030D-6E8A-4147-A177-3AD203B41FA5}">
+                      <a16:colId xmlns:a16="http://schemas.microsoft.com/office/drawing/2014/main" val="2948238244"/>
+                    </a:ext>
+                  </a:extLst>
+                </a:gridCol>
+                <a:gridCol w="1384056">
+                  <a:extLst>
+                    <a:ext uri="{9D8B030D-6E8A-4147-A177-3AD203B41FA5}">
+                      <a16:colId xmlns:a16="http://schemas.microsoft.com/office/drawing/2014/main" val="1499066006"/>
+                    </a:ext>
+                  </a:extLst>
+                </a:gridCol>
+              </a:tblGrid>
+              <a:tr h="370840">
+                <a:tc>
+                  <a:txBody>
+                    <a:bodyPr/>
+                    <a:lstStyle/>
+                    <a:p>
+                      <a:r>
+                        <a:rPr lang="en-US" dirty="0"/>
+                        <a:t>Name</a:t>
+                      </a:r>
+                      <a:endParaRPr lang="en-IN" dirty="0"/>
+                    </a:p>
+                  </a:txBody>
+                  <a:tcPr>
+                    <a:lnL w="12700" cap="flat" cmpd="sng" algn="ctr">
+                      <a:solidFill>
+                        <a:schemeClr val="tx1"/>
+                      </a:solidFill>
+                      <a:prstDash val="solid"/>
+                      <a:round/>
+                      <a:headEnd type="none" w="med" len="med"/>
+                      <a:tailEnd type="none" w="med" len="med"/>
+                    </a:lnL>
+                    <a:lnR w="12700" cap="flat" cmpd="sng" algn="ctr">
+                      <a:solidFill>
+                        <a:schemeClr val="tx1"/>
+                      </a:solidFill>
+                      <a:prstDash val="solid"/>
+                      <a:round/>
+                      <a:headEnd type="none" w="med" len="med"/>
+                      <a:tailEnd type="none" w="med" len="med"/>
+                    </a:lnR>
+                    <a:lnT w="12700" cap="flat" cmpd="sng" algn="ctr">
+                      <a:solidFill>
+                        <a:schemeClr val="tx1"/>
+                      </a:solidFill>
+                      <a:prstDash val="solid"/>
+                      <a:round/>
+                      <a:headEnd type="none" w="med" len="med"/>
+                      <a:tailEnd type="none" w="med" len="med"/>
+                    </a:lnT>
+                    <a:lnB w="12700" cap="flat" cmpd="sng" algn="ctr">
+                      <a:solidFill>
+                        <a:schemeClr val="tx1"/>
+                      </a:solidFill>
+                      <a:prstDash val="solid"/>
+                      <a:round/>
+                      <a:headEnd type="none" w="med" len="med"/>
+                      <a:tailEnd type="none" w="med" len="med"/>
+                    </a:lnB>
+                    <a:solidFill>
+                      <a:schemeClr val="accent1">
+                        <a:lumMod val="75000"/>
+                      </a:schemeClr>
+                    </a:solidFill>
+                  </a:tcPr>
+                </a:tc>
+                <a:tc>
+                  <a:txBody>
+                    <a:bodyPr/>
+                    <a:lstStyle/>
+                    <a:p>
+                      <a:r>
+                        <a:rPr lang="en-US" dirty="0"/>
+                        <a:t>Position</a:t>
+                      </a:r>
+                      <a:endParaRPr lang="en-IN" dirty="0"/>
+                    </a:p>
+                  </a:txBody>
+                  <a:tcPr>
+                    <a:lnL w="12700" cap="flat" cmpd="sng" algn="ctr">
+                      <a:solidFill>
+                        <a:schemeClr val="tx1"/>
+                      </a:solidFill>
+                      <a:prstDash val="solid"/>
+                      <a:round/>
+                      <a:headEnd type="none" w="med" len="med"/>
+                      <a:tailEnd type="none" w="med" len="med"/>
+                    </a:lnL>
+                    <a:lnR w="12700" cap="flat" cmpd="sng" algn="ctr">
+                      <a:solidFill>
+                        <a:schemeClr val="tx1"/>
+                      </a:solidFill>
+                      <a:prstDash val="solid"/>
+                      <a:round/>
+                      <a:headEnd type="none" w="med" len="med"/>
+                      <a:tailEnd type="none" w="med" len="med"/>
+                    </a:lnR>
+                    <a:lnT w="12700" cap="flat" cmpd="sng" algn="ctr">
+                      <a:solidFill>
+                        <a:schemeClr val="tx1"/>
+                      </a:solidFill>
+                      <a:prstDash val="solid"/>
+                      <a:round/>
+                      <a:headEnd type="none" w="med" len="med"/>
+                      <a:tailEnd type="none" w="med" len="med"/>
+                    </a:lnT>
+                    <a:lnB w="12700" cap="flat" cmpd="sng" algn="ctr">
+                      <a:solidFill>
+                        <a:schemeClr val="tx1"/>
+                      </a:solidFill>
+                      <a:prstDash val="solid"/>
+                      <a:round/>
+                      <a:headEnd type="none" w="med" len="med"/>
+                      <a:tailEnd type="none" w="med" len="med"/>
+                    </a:lnB>
+                    <a:solidFill>
+                      <a:schemeClr val="accent1">
+                        <a:lumMod val="75000"/>
+                      </a:schemeClr>
+                    </a:solidFill>
+                  </a:tcPr>
+                </a:tc>
+                <a:tc>
+                  <a:txBody>
+                    <a:bodyPr/>
+                    <a:lstStyle/>
+                    <a:p>
+                      <a:r>
+                        <a:rPr lang="en-US" dirty="0"/>
+                        <a:t>Net Salary</a:t>
+                      </a:r>
+                      <a:endParaRPr lang="en-IN" dirty="0"/>
+                    </a:p>
+                  </a:txBody>
+                  <a:tcPr>
+                    <a:lnL w="12700" cap="flat" cmpd="sng" algn="ctr">
+                      <a:solidFill>
+                        <a:schemeClr val="tx1"/>
+                      </a:solidFill>
+                      <a:prstDash val="solid"/>
+                      <a:round/>
+                      <a:headEnd type="none" w="med" len="med"/>
+                      <a:tailEnd type="none" w="med" len="med"/>
+                    </a:lnL>
+                    <a:lnR w="12700" cap="flat" cmpd="sng" algn="ctr">
+                      <a:solidFill>
+                        <a:schemeClr val="tx1"/>
+                      </a:solidFill>
+                      <a:prstDash val="solid"/>
+                      <a:round/>
+                      <a:headEnd type="none" w="med" len="med"/>
+                      <a:tailEnd type="none" w="med" len="med"/>
+                    </a:lnR>
+                    <a:lnT w="12700" cap="flat" cmpd="sng" algn="ctr">
+                      <a:solidFill>
+                        <a:schemeClr val="tx1"/>
+                      </a:solidFill>
+                      <a:prstDash val="solid"/>
+                      <a:round/>
+                      <a:headEnd type="none" w="med" len="med"/>
+                      <a:tailEnd type="none" w="med" len="med"/>
+                    </a:lnT>
+                    <a:lnB w="12700" cap="flat" cmpd="sng" algn="ctr">
+                      <a:solidFill>
+                        <a:schemeClr val="tx1"/>
+                      </a:solidFill>
+                      <a:prstDash val="solid"/>
+                      <a:round/>
+                      <a:headEnd type="none" w="med" len="med"/>
+                      <a:tailEnd type="none" w="med" len="med"/>
+                    </a:lnB>
+                    <a:solidFill>
+                      <a:schemeClr val="accent1">
+                        <a:lumMod val="75000"/>
+                      </a:schemeClr>
+                    </a:solidFill>
+                  </a:tcPr>
+                </a:tc>
+                <a:tc>
+                  <a:txBody>
+                    <a:bodyPr/>
+                    <a:lstStyle/>
+                    <a:p>
+                      <a:r>
+                        <a:rPr lang="en-US" dirty="0"/>
+                        <a:t>Status</a:t>
+                      </a:r>
+                      <a:endParaRPr lang="en-IN" dirty="0"/>
+                    </a:p>
+                  </a:txBody>
+                  <a:tcPr>
+                    <a:lnL w="12700" cap="flat" cmpd="sng" algn="ctr">
+                      <a:solidFill>
+                        <a:schemeClr val="tx1"/>
+                      </a:solidFill>
+                      <a:prstDash val="solid"/>
+                      <a:round/>
+                      <a:headEnd type="none" w="med" len="med"/>
+                      <a:tailEnd type="none" w="med" len="med"/>
+                    </a:lnL>
+                    <a:lnR w="12700" cap="flat" cmpd="sng" algn="ctr">
+                      <a:solidFill>
+                        <a:schemeClr val="tx1"/>
+                      </a:solidFill>
+                      <a:prstDash val="solid"/>
+                      <a:round/>
+                      <a:headEnd type="none" w="med" len="med"/>
+                      <a:tailEnd type="none" w="med" len="med"/>
+                    </a:lnR>
+                    <a:lnT w="12700" cap="flat" cmpd="sng" algn="ctr">
+                      <a:solidFill>
+                        <a:schemeClr val="tx1"/>
+                      </a:solidFill>
+                      <a:prstDash val="solid"/>
+                      <a:round/>
+                      <a:headEnd type="none" w="med" len="med"/>
+                      <a:tailEnd type="none" w="med" len="med"/>
+                    </a:lnT>
+                    <a:lnB w="12700" cap="flat" cmpd="sng" algn="ctr">
+                      <a:solidFill>
+                        <a:schemeClr val="tx1"/>
+                      </a:solidFill>
+                      <a:prstDash val="solid"/>
+                      <a:round/>
+                      <a:headEnd type="none" w="med" len="med"/>
+                      <a:tailEnd type="none" w="med" len="med"/>
+                    </a:lnB>
+                    <a:solidFill>
+                      <a:schemeClr val="accent1">
+                        <a:lumMod val="75000"/>
+                      </a:schemeClr>
+                    </a:solidFill>
+                  </a:tcPr>
+                </a:tc>
+                <a:extLst>
+                  <a:ext uri="{0D108BD9-81ED-4DB2-BD59-A6C34878D82A}">
+                    <a16:rowId xmlns:a16="http://schemas.microsoft.com/office/drawing/2014/main" val="2967609491"/>
+                  </a:ext>
+                </a:extLst>
+              </a:tr>
+              <a:tr h="370840">
+                <a:tc>
+                  <a:txBody>
+                    <a:bodyPr/>
+                    <a:lstStyle/>
+                    <a:p>
+                      <a:endParaRPr lang="en-IN" dirty="0"/>
+                    </a:p>
+                  </a:txBody>
+                  <a:tcPr>
+                    <a:lnL w="12700" cap="flat" cmpd="sng" algn="ctr">
+                      <a:solidFill>
+                        <a:schemeClr val="tx1"/>
+                      </a:solidFill>
+                      <a:prstDash val="solid"/>
+                      <a:round/>
+                      <a:headEnd type="none" w="med" len="med"/>
+                      <a:tailEnd type="none" w="med" len="med"/>
+                    </a:lnL>
+                    <a:lnR w="12700" cap="flat" cmpd="sng" algn="ctr">
+                      <a:solidFill>
+                        <a:schemeClr val="tx1"/>
+                      </a:solidFill>
+                      <a:prstDash val="solid"/>
+                      <a:round/>
+                      <a:headEnd type="none" w="med" len="med"/>
+                      <a:tailEnd type="none" w="med" len="med"/>
+                    </a:lnR>
+                    <a:lnT w="12700" cap="flat" cmpd="sng" algn="ctr">
+                      <a:solidFill>
+                        <a:schemeClr val="tx1"/>
+                      </a:solidFill>
+                      <a:prstDash val="solid"/>
+                      <a:round/>
+                      <a:headEnd type="none" w="med" len="med"/>
+                      <a:tailEnd type="none" w="med" len="med"/>
+                    </a:lnT>
+                    <a:lnB w="12700" cap="flat" cmpd="sng" algn="ctr">
+                      <a:solidFill>
+                        <a:schemeClr val="tx1"/>
+                      </a:solidFill>
+                      <a:prstDash val="solid"/>
+                      <a:round/>
+                      <a:headEnd type="none" w="med" len="med"/>
+                      <a:tailEnd type="none" w="med" len="med"/>
+                    </a:lnB>
+                    <a:solidFill>
+                      <a:srgbClr val="8FAADC"/>
+                    </a:solidFill>
+                  </a:tcPr>
+                </a:tc>
+                <a:tc>
+                  <a:txBody>
+                    <a:bodyPr/>
+                    <a:lstStyle/>
+                    <a:p>
+                      <a:endParaRPr lang="en-IN"/>
+                    </a:p>
+                  </a:txBody>
+                  <a:tcPr>
+                    <a:lnL w="12700" cap="flat" cmpd="sng" algn="ctr">
+                      <a:solidFill>
+                        <a:schemeClr val="tx1"/>
+                      </a:solidFill>
+                      <a:prstDash val="solid"/>
+                      <a:round/>
+                      <a:headEnd type="none" w="med" len="med"/>
+                      <a:tailEnd type="none" w="med" len="med"/>
+                    </a:lnL>
+                    <a:lnR w="12700" cap="flat" cmpd="sng" algn="ctr">
+                      <a:solidFill>
+                        <a:schemeClr val="tx1"/>
+                      </a:solidFill>
+                      <a:prstDash val="solid"/>
+                      <a:round/>
+                      <a:headEnd type="none" w="med" len="med"/>
+                      <a:tailEnd type="none" w="med" len="med"/>
+                    </a:lnR>
+                    <a:lnT w="12700" cap="flat" cmpd="sng" algn="ctr">
+                      <a:solidFill>
+                        <a:schemeClr val="tx1"/>
+                      </a:solidFill>
+                      <a:prstDash val="solid"/>
+                      <a:round/>
+                      <a:headEnd type="none" w="med" len="med"/>
+                      <a:tailEnd type="none" w="med" len="med"/>
+                    </a:lnT>
+                    <a:lnB w="12700" cap="flat" cmpd="sng" algn="ctr">
+                      <a:solidFill>
+                        <a:schemeClr val="tx1"/>
+                      </a:solidFill>
+                      <a:prstDash val="solid"/>
+                      <a:round/>
+                      <a:headEnd type="none" w="med" len="med"/>
+                      <a:tailEnd type="none" w="med" len="med"/>
+                    </a:lnB>
+                    <a:solidFill>
+                      <a:srgbClr val="8FAADC"/>
+                    </a:solidFill>
+                  </a:tcPr>
+                </a:tc>
+                <a:tc>
+                  <a:txBody>
+                    <a:bodyPr/>
+                    <a:lstStyle/>
+                    <a:p>
+                      <a:endParaRPr lang="en-IN"/>
+                    </a:p>
+                  </a:txBody>
+                  <a:tcPr>
+                    <a:lnL w="12700" cap="flat" cmpd="sng" algn="ctr">
+                      <a:solidFill>
+                        <a:schemeClr val="tx1"/>
+                      </a:solidFill>
+                      <a:prstDash val="solid"/>
+                      <a:round/>
+                      <a:headEnd type="none" w="med" len="med"/>
+                      <a:tailEnd type="none" w="med" len="med"/>
+                    </a:lnL>
+                    <a:lnR w="12700" cap="flat" cmpd="sng" algn="ctr">
+                      <a:solidFill>
+                        <a:schemeClr val="tx1"/>
+                      </a:solidFill>
+                      <a:prstDash val="solid"/>
+                      <a:round/>
+                      <a:headEnd type="none" w="med" len="med"/>
+                      <a:tailEnd type="none" w="med" len="med"/>
+                    </a:lnR>
+                    <a:lnT w="12700" cap="flat" cmpd="sng" algn="ctr">
+                      <a:solidFill>
+                        <a:schemeClr val="tx1"/>
+                      </a:solidFill>
+                      <a:prstDash val="solid"/>
+                      <a:round/>
+                      <a:headEnd type="none" w="med" len="med"/>
+                      <a:tailEnd type="none" w="med" len="med"/>
+                    </a:lnT>
+                    <a:lnB w="12700" cap="flat" cmpd="sng" algn="ctr">
+                      <a:solidFill>
+                        <a:schemeClr val="tx1"/>
+                      </a:solidFill>
+                      <a:prstDash val="solid"/>
+                      <a:round/>
+                      <a:headEnd type="none" w="med" len="med"/>
+                      <a:tailEnd type="none" w="med" len="med"/>
+                    </a:lnB>
+                    <a:solidFill>
+                      <a:srgbClr val="8FAADC"/>
+                    </a:solidFill>
+                  </a:tcPr>
+                </a:tc>
+                <a:tc>
+                  <a:txBody>
+                    <a:bodyPr/>
+                    <a:lstStyle/>
+                    <a:p>
+                      <a:endParaRPr lang="en-IN"/>
+                    </a:p>
+                  </a:txBody>
+                  <a:tcPr>
+                    <a:lnL w="12700" cap="flat" cmpd="sng" algn="ctr">
+                      <a:solidFill>
+                        <a:schemeClr val="tx1"/>
+                      </a:solidFill>
+                      <a:prstDash val="solid"/>
+                      <a:round/>
+                      <a:headEnd type="none" w="med" len="med"/>
+                      <a:tailEnd type="none" w="med" len="med"/>
+                    </a:lnL>
+                    <a:lnR w="12700" cap="flat" cmpd="sng" algn="ctr">
+                      <a:solidFill>
+                        <a:schemeClr val="tx1"/>
+                      </a:solidFill>
+                      <a:prstDash val="solid"/>
+                      <a:round/>
+                      <a:headEnd type="none" w="med" len="med"/>
+                      <a:tailEnd type="none" w="med" len="med"/>
+                    </a:lnR>
+                    <a:lnT w="12700" cap="flat" cmpd="sng" algn="ctr">
+                      <a:solidFill>
+                        <a:schemeClr val="tx1"/>
+                      </a:solidFill>
+                      <a:prstDash val="solid"/>
+                      <a:round/>
+                      <a:headEnd type="none" w="med" len="med"/>
+                      <a:tailEnd type="none" w="med" len="med"/>
+                    </a:lnT>
+                    <a:lnB w="12700" cap="flat" cmpd="sng" algn="ctr">
+                      <a:solidFill>
+                        <a:schemeClr val="tx1"/>
+                      </a:solidFill>
+                      <a:prstDash val="solid"/>
+                      <a:round/>
+                      <a:headEnd type="none" w="med" len="med"/>
+                      <a:tailEnd type="none" w="med" len="med"/>
+                    </a:lnB>
+                    <a:solidFill>
+                      <a:srgbClr val="8FAADC"/>
+                    </a:solidFill>
+                  </a:tcPr>
+                </a:tc>
+                <a:extLst>
+                  <a:ext uri="{0D108BD9-81ED-4DB2-BD59-A6C34878D82A}">
+                    <a16:rowId xmlns:a16="http://schemas.microsoft.com/office/drawing/2014/main" val="1665693499"/>
+                  </a:ext>
+                </a:extLst>
+              </a:tr>
+              <a:tr h="370840">
+                <a:tc>
+                  <a:txBody>
+                    <a:bodyPr/>
+                    <a:lstStyle/>
+                    <a:p>
+                      <a:endParaRPr lang="en-IN" dirty="0"/>
+                    </a:p>
+                  </a:txBody>
+                  <a:tcPr>
+                    <a:lnL w="12700" cap="flat" cmpd="sng" algn="ctr">
+                      <a:solidFill>
+                        <a:schemeClr val="tx1"/>
+                      </a:solidFill>
+                      <a:prstDash val="solid"/>
+                      <a:round/>
+                      <a:headEnd type="none" w="med" len="med"/>
+                      <a:tailEnd type="none" w="med" len="med"/>
+                    </a:lnL>
+                    <a:lnR w="12700" cap="flat" cmpd="sng" algn="ctr">
+                      <a:solidFill>
+                        <a:schemeClr val="tx1"/>
+                      </a:solidFill>
+                      <a:prstDash val="solid"/>
+                      <a:round/>
+                      <a:headEnd type="none" w="med" len="med"/>
+                      <a:tailEnd type="none" w="med" len="med"/>
+                    </a:lnR>
+                    <a:lnT w="12700" cap="flat" cmpd="sng" algn="ctr">
+                      <a:solidFill>
+                        <a:schemeClr val="tx1"/>
+                      </a:solidFill>
+                      <a:prstDash val="solid"/>
+                      <a:round/>
+                      <a:headEnd type="none" w="med" len="med"/>
+                      <a:tailEnd type="none" w="med" len="med"/>
+                    </a:lnT>
+                    <a:lnB w="12700" cap="flat" cmpd="sng" algn="ctr">
+                      <a:solidFill>
+                        <a:schemeClr val="tx1"/>
+                      </a:solidFill>
+                      <a:prstDash val="solid"/>
+                      <a:round/>
+                      <a:headEnd type="none" w="med" len="med"/>
+                      <a:tailEnd type="none" w="med" len="med"/>
+                    </a:lnB>
+                    <a:solidFill>
+                      <a:srgbClr val="8FAADC"/>
+                    </a:solidFill>
+                  </a:tcPr>
+                </a:tc>
+                <a:tc>
+                  <a:txBody>
+                    <a:bodyPr/>
+                    <a:lstStyle/>
+                    <a:p>
+                      <a:endParaRPr lang="en-IN" dirty="0"/>
+                    </a:p>
+                  </a:txBody>
+                  <a:tcPr>
+                    <a:lnL w="12700" cap="flat" cmpd="sng" algn="ctr">
+                      <a:solidFill>
+                        <a:schemeClr val="tx1"/>
+                      </a:solidFill>
+                      <a:prstDash val="solid"/>
+                      <a:round/>
+                      <a:headEnd type="none" w="med" len="med"/>
+                      <a:tailEnd type="none" w="med" len="med"/>
+                    </a:lnL>
+                    <a:lnR w="12700" cap="flat" cmpd="sng" algn="ctr">
+                      <a:solidFill>
+                        <a:schemeClr val="tx1"/>
+                      </a:solidFill>
+                      <a:prstDash val="solid"/>
+                      <a:round/>
+                      <a:headEnd type="none" w="med" len="med"/>
+                      <a:tailEnd type="none" w="med" len="med"/>
+                    </a:lnR>
+                    <a:lnT w="12700" cap="flat" cmpd="sng" algn="ctr">
+                      <a:solidFill>
+                        <a:schemeClr val="tx1"/>
+                      </a:solidFill>
+                      <a:prstDash val="solid"/>
+                      <a:round/>
+                      <a:headEnd type="none" w="med" len="med"/>
+                      <a:tailEnd type="none" w="med" len="med"/>
+                    </a:lnT>
+                    <a:lnB w="12700" cap="flat" cmpd="sng" algn="ctr">
+                      <a:solidFill>
+                        <a:schemeClr val="tx1"/>
+                      </a:solidFill>
+                      <a:prstDash val="solid"/>
+                      <a:round/>
+                      <a:headEnd type="none" w="med" len="med"/>
+                      <a:tailEnd type="none" w="med" len="med"/>
+                    </a:lnB>
+                    <a:solidFill>
+                      <a:srgbClr val="8FAADC"/>
+                    </a:solidFill>
+                  </a:tcPr>
+                </a:tc>
+                <a:tc>
+                  <a:txBody>
+                    <a:bodyPr/>
+                    <a:lstStyle/>
+                    <a:p>
+                      <a:endParaRPr lang="en-IN"/>
+                    </a:p>
+                  </a:txBody>
+                  <a:tcPr>
+                    <a:lnL w="12700" cap="flat" cmpd="sng" algn="ctr">
+                      <a:solidFill>
+                        <a:schemeClr val="tx1"/>
+                      </a:solidFill>
+                      <a:prstDash val="solid"/>
+                      <a:round/>
+                      <a:headEnd type="none" w="med" len="med"/>
+                      <a:tailEnd type="none" w="med" len="med"/>
+                    </a:lnL>
+                    <a:lnR w="12700" cap="flat" cmpd="sng" algn="ctr">
+                      <a:solidFill>
+                        <a:schemeClr val="tx1"/>
+                      </a:solidFill>
+                      <a:prstDash val="solid"/>
+                      <a:round/>
+                      <a:headEnd type="none" w="med" len="med"/>
+                      <a:tailEnd type="none" w="med" len="med"/>
+                    </a:lnR>
+                    <a:lnT w="12700" cap="flat" cmpd="sng" algn="ctr">
+                      <a:solidFill>
+                        <a:schemeClr val="tx1"/>
+                      </a:solidFill>
+                      <a:prstDash val="solid"/>
+                      <a:round/>
+                      <a:headEnd type="none" w="med" len="med"/>
+                      <a:tailEnd type="none" w="med" len="med"/>
+                    </a:lnT>
+                    <a:lnB w="12700" cap="flat" cmpd="sng" algn="ctr">
+                      <a:solidFill>
+                        <a:schemeClr val="tx1"/>
+                      </a:solidFill>
+                      <a:prstDash val="solid"/>
+                      <a:round/>
+                      <a:headEnd type="none" w="med" len="med"/>
+                      <a:tailEnd type="none" w="med" len="med"/>
+                    </a:lnB>
+                    <a:solidFill>
+                      <a:srgbClr val="8FAADC"/>
+                    </a:solidFill>
+                  </a:tcPr>
+                </a:tc>
+                <a:tc>
+                  <a:txBody>
+                    <a:bodyPr/>
+                    <a:lstStyle/>
+                    <a:p>
+                      <a:endParaRPr lang="en-IN"/>
+                    </a:p>
+                  </a:txBody>
+                  <a:tcPr>
+                    <a:lnL w="12700" cap="flat" cmpd="sng" algn="ctr">
+                      <a:solidFill>
+                        <a:schemeClr val="tx1"/>
+                      </a:solidFill>
+                      <a:prstDash val="solid"/>
+                      <a:round/>
+                      <a:headEnd type="none" w="med" len="med"/>
+                      <a:tailEnd type="none" w="med" len="med"/>
+                    </a:lnL>
+                    <a:lnR w="12700" cap="flat" cmpd="sng" algn="ctr">
+                      <a:solidFill>
+                        <a:schemeClr val="tx1"/>
+                      </a:solidFill>
+                      <a:prstDash val="solid"/>
+                      <a:round/>
+                      <a:headEnd type="none" w="med" len="med"/>
+                      <a:tailEnd type="none" w="med" len="med"/>
+                    </a:lnR>
+                    <a:lnT w="12700" cap="flat" cmpd="sng" algn="ctr">
+                      <a:solidFill>
+                        <a:schemeClr val="tx1"/>
+                      </a:solidFill>
+                      <a:prstDash val="solid"/>
+                      <a:round/>
+                      <a:headEnd type="none" w="med" len="med"/>
+                      <a:tailEnd type="none" w="med" len="med"/>
+                    </a:lnT>
+                    <a:lnB w="12700" cap="flat" cmpd="sng" algn="ctr">
+                      <a:solidFill>
+                        <a:schemeClr val="tx1"/>
+                      </a:solidFill>
+                      <a:prstDash val="solid"/>
+                      <a:round/>
+                      <a:headEnd type="none" w="med" len="med"/>
+                      <a:tailEnd type="none" w="med" len="med"/>
+                    </a:lnB>
+                    <a:solidFill>
+                      <a:srgbClr val="8FAADC"/>
+                    </a:solidFill>
+                  </a:tcPr>
+                </a:tc>
+                <a:extLst>
+                  <a:ext uri="{0D108BD9-81ED-4DB2-BD59-A6C34878D82A}">
+                    <a16:rowId xmlns:a16="http://schemas.microsoft.com/office/drawing/2014/main" val="1485392036"/>
+                  </a:ext>
+                </a:extLst>
+              </a:tr>
+              <a:tr h="370840">
+                <a:tc>
+                  <a:txBody>
+                    <a:bodyPr/>
+                    <a:lstStyle/>
+                    <a:p>
+                      <a:endParaRPr lang="en-IN"/>
+                    </a:p>
+                  </a:txBody>
+                  <a:tcPr>
+                    <a:lnL w="12700" cap="flat" cmpd="sng" algn="ctr">
+                      <a:solidFill>
+                        <a:schemeClr val="tx1"/>
+                      </a:solidFill>
+                      <a:prstDash val="solid"/>
+                      <a:round/>
+                      <a:headEnd type="none" w="med" len="med"/>
+                      <a:tailEnd type="none" w="med" len="med"/>
+                    </a:lnL>
+                    <a:lnR w="12700" cap="flat" cmpd="sng" algn="ctr">
+                      <a:solidFill>
+                        <a:schemeClr val="tx1"/>
+                      </a:solidFill>
+                      <a:prstDash val="solid"/>
+                      <a:round/>
+                      <a:headEnd type="none" w="med" len="med"/>
+                      <a:tailEnd type="none" w="med" len="med"/>
+                    </a:lnR>
+                    <a:lnT w="12700" cap="flat" cmpd="sng" algn="ctr">
+                      <a:solidFill>
+                        <a:schemeClr val="tx1"/>
+                      </a:solidFill>
+                      <a:prstDash val="solid"/>
+                      <a:round/>
+                      <a:headEnd type="none" w="med" len="med"/>
+                      <a:tailEnd type="none" w="med" len="med"/>
+                    </a:lnT>
+                    <a:lnB w="12700" cap="flat" cmpd="sng" algn="ctr">
+                      <a:solidFill>
+                        <a:schemeClr val="tx1"/>
+                      </a:solidFill>
+                      <a:prstDash val="solid"/>
+                      <a:round/>
+                      <a:headEnd type="none" w="med" len="med"/>
+                      <a:tailEnd type="none" w="med" len="med"/>
+                    </a:lnB>
+                    <a:solidFill>
+                      <a:srgbClr val="8FAADC"/>
+                    </a:solidFill>
+                  </a:tcPr>
+                </a:tc>
+                <a:tc>
+                  <a:txBody>
+                    <a:bodyPr/>
+                    <a:lstStyle/>
+                    <a:p>
+                      <a:endParaRPr lang="en-IN" dirty="0"/>
+                    </a:p>
+                  </a:txBody>
+                  <a:tcPr>
+                    <a:lnL w="12700" cap="flat" cmpd="sng" algn="ctr">
+                      <a:solidFill>
+                        <a:schemeClr val="tx1"/>
+                      </a:solidFill>
+                      <a:prstDash val="solid"/>
+                      <a:round/>
+                      <a:headEnd type="none" w="med" len="med"/>
+                      <a:tailEnd type="none" w="med" len="med"/>
+                    </a:lnL>
+                    <a:lnR w="12700" cap="flat" cmpd="sng" algn="ctr">
+                      <a:solidFill>
+                        <a:schemeClr val="tx1"/>
+                      </a:solidFill>
+                      <a:prstDash val="solid"/>
+                      <a:round/>
+                      <a:headEnd type="none" w="med" len="med"/>
+                      <a:tailEnd type="none" w="med" len="med"/>
+                    </a:lnR>
+                    <a:lnT w="12700" cap="flat" cmpd="sng" algn="ctr">
+                      <a:solidFill>
+                        <a:schemeClr val="tx1"/>
+                      </a:solidFill>
+                      <a:prstDash val="solid"/>
+                      <a:round/>
+                      <a:headEnd type="none" w="med" len="med"/>
+                      <a:tailEnd type="none" w="med" len="med"/>
+                    </a:lnT>
+                    <a:lnB w="12700" cap="flat" cmpd="sng" algn="ctr">
+                      <a:solidFill>
+                        <a:schemeClr val="tx1"/>
+                      </a:solidFill>
+                      <a:prstDash val="solid"/>
+                      <a:round/>
+                      <a:headEnd type="none" w="med" len="med"/>
+                      <a:tailEnd type="none" w="med" len="med"/>
+                    </a:lnB>
+                    <a:solidFill>
+                      <a:srgbClr val="8FAADC"/>
+                    </a:solidFill>
+                  </a:tcPr>
+                </a:tc>
+                <a:tc>
+                  <a:txBody>
+                    <a:bodyPr/>
+                    <a:lstStyle/>
+                    <a:p>
+                      <a:endParaRPr lang="en-IN"/>
+                    </a:p>
+                  </a:txBody>
+                  <a:tcPr>
+                    <a:lnL w="12700" cap="flat" cmpd="sng" algn="ctr">
+                      <a:solidFill>
+                        <a:schemeClr val="tx1"/>
+                      </a:solidFill>
+                      <a:prstDash val="solid"/>
+                      <a:round/>
+                      <a:headEnd type="none" w="med" len="med"/>
+                      <a:tailEnd type="none" w="med" len="med"/>
+                    </a:lnL>
+                    <a:lnR w="12700" cap="flat" cmpd="sng" algn="ctr">
+                      <a:solidFill>
+                        <a:schemeClr val="tx1"/>
+                      </a:solidFill>
+                      <a:prstDash val="solid"/>
+                      <a:round/>
+                      <a:headEnd type="none" w="med" len="med"/>
+                      <a:tailEnd type="none" w="med" len="med"/>
+                    </a:lnR>
+                    <a:lnT w="12700" cap="flat" cmpd="sng" algn="ctr">
+                      <a:solidFill>
+                        <a:schemeClr val="tx1"/>
+                      </a:solidFill>
+                      <a:prstDash val="solid"/>
+                      <a:round/>
+                      <a:headEnd type="none" w="med" len="med"/>
+                      <a:tailEnd type="none" w="med" len="med"/>
+                    </a:lnT>
+                    <a:lnB w="12700" cap="flat" cmpd="sng" algn="ctr">
+                      <a:solidFill>
+                        <a:schemeClr val="tx1"/>
+                      </a:solidFill>
+                      <a:prstDash val="solid"/>
+                      <a:round/>
+                      <a:headEnd type="none" w="med" len="med"/>
+                      <a:tailEnd type="none" w="med" len="med"/>
+                    </a:lnB>
+                    <a:solidFill>
+                      <a:srgbClr val="8FAADC"/>
+                    </a:solidFill>
+                  </a:tcPr>
+                </a:tc>
+                <a:tc>
+                  <a:txBody>
+                    <a:bodyPr/>
+                    <a:lstStyle/>
+                    <a:p>
+                      <a:endParaRPr lang="en-IN"/>
+                    </a:p>
+                  </a:txBody>
+                  <a:tcPr>
+                    <a:lnL w="12700" cap="flat" cmpd="sng" algn="ctr">
+                      <a:solidFill>
+                        <a:schemeClr val="tx1"/>
+                      </a:solidFill>
+                      <a:prstDash val="solid"/>
+                      <a:round/>
+                      <a:headEnd type="none" w="med" len="med"/>
+                      <a:tailEnd type="none" w="med" len="med"/>
+                    </a:lnL>
+                    <a:lnR w="12700" cap="flat" cmpd="sng" algn="ctr">
+                      <a:solidFill>
+                        <a:schemeClr val="tx1"/>
+                      </a:solidFill>
+                      <a:prstDash val="solid"/>
+                      <a:round/>
+                      <a:headEnd type="none" w="med" len="med"/>
+                      <a:tailEnd type="none" w="med" len="med"/>
+                    </a:lnR>
+                    <a:lnT w="12700" cap="flat" cmpd="sng" algn="ctr">
+                      <a:solidFill>
+                        <a:schemeClr val="tx1"/>
+                      </a:solidFill>
+                      <a:prstDash val="solid"/>
+                      <a:round/>
+                      <a:headEnd type="none" w="med" len="med"/>
+                      <a:tailEnd type="none" w="med" len="med"/>
+                    </a:lnT>
+                    <a:lnB w="12700" cap="flat" cmpd="sng" algn="ctr">
+                      <a:solidFill>
+                        <a:schemeClr val="tx1"/>
+                      </a:solidFill>
+                      <a:prstDash val="solid"/>
+                      <a:round/>
+                      <a:headEnd type="none" w="med" len="med"/>
+                      <a:tailEnd type="none" w="med" len="med"/>
+                    </a:lnB>
+                    <a:solidFill>
+                      <a:srgbClr val="8FAADC"/>
+                    </a:solidFill>
+                  </a:tcPr>
+                </a:tc>
+                <a:extLst>
+                  <a:ext uri="{0D108BD9-81ED-4DB2-BD59-A6C34878D82A}">
+                    <a16:rowId xmlns:a16="http://schemas.microsoft.com/office/drawing/2014/main" val="430668479"/>
+                  </a:ext>
+                </a:extLst>
+              </a:tr>
+              <a:tr h="370840">
+                <a:tc>
+                  <a:txBody>
+                    <a:bodyPr/>
+                    <a:lstStyle/>
+                    <a:p>
+                      <a:endParaRPr lang="en-IN"/>
+                    </a:p>
+                  </a:txBody>
+                  <a:tcPr>
+                    <a:lnL w="12700" cap="flat" cmpd="sng" algn="ctr">
+                      <a:solidFill>
+                        <a:schemeClr val="tx1"/>
+                      </a:solidFill>
+                      <a:prstDash val="solid"/>
+                      <a:round/>
+                      <a:headEnd type="none" w="med" len="med"/>
+                      <a:tailEnd type="none" w="med" len="med"/>
+                    </a:lnL>
+                    <a:lnR w="12700" cap="flat" cmpd="sng" algn="ctr">
+                      <a:solidFill>
+                        <a:schemeClr val="tx1"/>
+                      </a:solidFill>
+                      <a:prstDash val="solid"/>
+                      <a:round/>
+                      <a:headEnd type="none" w="med" len="med"/>
+                      <a:tailEnd type="none" w="med" len="med"/>
+                    </a:lnR>
+                    <a:lnT w="12700" cap="flat" cmpd="sng" algn="ctr">
+                      <a:solidFill>
+                        <a:schemeClr val="tx1"/>
+                      </a:solidFill>
+                      <a:prstDash val="solid"/>
+                      <a:round/>
+                      <a:headEnd type="none" w="med" len="med"/>
+                      <a:tailEnd type="none" w="med" len="med"/>
+                    </a:lnT>
+                    <a:lnB w="12700" cap="flat" cmpd="sng" algn="ctr">
+                      <a:solidFill>
+                        <a:schemeClr val="tx1"/>
+                      </a:solidFill>
+                      <a:prstDash val="solid"/>
+                      <a:round/>
+                      <a:headEnd type="none" w="med" len="med"/>
+                      <a:tailEnd type="none" w="med" len="med"/>
+                    </a:lnB>
+                    <a:solidFill>
+                      <a:srgbClr val="8FAADC"/>
+                    </a:solidFill>
+                  </a:tcPr>
+                </a:tc>
+                <a:tc>
+                  <a:txBody>
+                    <a:bodyPr/>
+                    <a:lstStyle/>
+                    <a:p>
+                      <a:endParaRPr lang="en-IN" dirty="0"/>
+                    </a:p>
+                  </a:txBody>
+                  <a:tcPr>
+                    <a:lnL w="12700" cap="flat" cmpd="sng" algn="ctr">
+                      <a:solidFill>
+                        <a:schemeClr val="tx1"/>
+                      </a:solidFill>
+                      <a:prstDash val="solid"/>
+                      <a:round/>
+                      <a:headEnd type="none" w="med" len="med"/>
+                      <a:tailEnd type="none" w="med" len="med"/>
+                    </a:lnL>
+                    <a:lnR w="12700" cap="flat" cmpd="sng" algn="ctr">
+                      <a:solidFill>
+                        <a:schemeClr val="tx1"/>
+                      </a:solidFill>
+                      <a:prstDash val="solid"/>
+                      <a:round/>
+                      <a:headEnd type="none" w="med" len="med"/>
+                      <a:tailEnd type="none" w="med" len="med"/>
+                    </a:lnR>
+                    <a:lnT w="12700" cap="flat" cmpd="sng" algn="ctr">
+                      <a:solidFill>
+                        <a:schemeClr val="tx1"/>
+                      </a:solidFill>
+                      <a:prstDash val="solid"/>
+                      <a:round/>
+                      <a:headEnd type="none" w="med" len="med"/>
+                      <a:tailEnd type="none" w="med" len="med"/>
+                    </a:lnT>
+                    <a:lnB w="12700" cap="flat" cmpd="sng" algn="ctr">
+                      <a:solidFill>
+                        <a:schemeClr val="tx1"/>
+                      </a:solidFill>
+                      <a:prstDash val="solid"/>
+                      <a:round/>
+                      <a:headEnd type="none" w="med" len="med"/>
+                      <a:tailEnd type="none" w="med" len="med"/>
+                    </a:lnB>
+                    <a:solidFill>
+                      <a:srgbClr val="8FAADC"/>
+                    </a:solidFill>
+                  </a:tcPr>
+                </a:tc>
+                <a:tc>
+                  <a:txBody>
+                    <a:bodyPr/>
+                    <a:lstStyle/>
+                    <a:p>
+                      <a:endParaRPr lang="en-IN"/>
+                    </a:p>
+                  </a:txBody>
+                  <a:tcPr>
+                    <a:lnL w="12700" cap="flat" cmpd="sng" algn="ctr">
+                      <a:solidFill>
+                        <a:schemeClr val="tx1"/>
+                      </a:solidFill>
+                      <a:prstDash val="solid"/>
+                      <a:round/>
+                      <a:headEnd type="none" w="med" len="med"/>
+                      <a:tailEnd type="none" w="med" len="med"/>
+                    </a:lnL>
+                    <a:lnR w="12700" cap="flat" cmpd="sng" algn="ctr">
+                      <a:solidFill>
+                        <a:schemeClr val="tx1"/>
+                      </a:solidFill>
+                      <a:prstDash val="solid"/>
+                      <a:round/>
+                      <a:headEnd type="none" w="med" len="med"/>
+                      <a:tailEnd type="none" w="med" len="med"/>
+                    </a:lnR>
+                    <a:lnT w="12700" cap="flat" cmpd="sng" algn="ctr">
+                      <a:solidFill>
+                        <a:schemeClr val="tx1"/>
+                      </a:solidFill>
+                      <a:prstDash val="solid"/>
+                      <a:round/>
+                      <a:headEnd type="none" w="med" len="med"/>
+                      <a:tailEnd type="none" w="med" len="med"/>
+                    </a:lnT>
+                    <a:lnB w="12700" cap="flat" cmpd="sng" algn="ctr">
+                      <a:solidFill>
+                        <a:schemeClr val="tx1"/>
+                      </a:solidFill>
+                      <a:prstDash val="solid"/>
+                      <a:round/>
+                      <a:headEnd type="none" w="med" len="med"/>
+                      <a:tailEnd type="none" w="med" len="med"/>
+                    </a:lnB>
+                    <a:solidFill>
+                      <a:srgbClr val="8FAADC"/>
+                    </a:solidFill>
+                  </a:tcPr>
+                </a:tc>
+                <a:tc>
+                  <a:txBody>
+                    <a:bodyPr/>
+                    <a:lstStyle/>
+                    <a:p>
+                      <a:endParaRPr lang="en-IN"/>
+                    </a:p>
+                  </a:txBody>
+                  <a:tcPr>
+                    <a:lnL w="12700" cap="flat" cmpd="sng" algn="ctr">
+                      <a:solidFill>
+                        <a:schemeClr val="tx1"/>
+                      </a:solidFill>
+                      <a:prstDash val="solid"/>
+                      <a:round/>
+                      <a:headEnd type="none" w="med" len="med"/>
+                      <a:tailEnd type="none" w="med" len="med"/>
+                    </a:lnL>
+                    <a:lnR w="12700" cap="flat" cmpd="sng" algn="ctr">
+                      <a:solidFill>
+                        <a:schemeClr val="tx1"/>
+                      </a:solidFill>
+                      <a:prstDash val="solid"/>
+                      <a:round/>
+                      <a:headEnd type="none" w="med" len="med"/>
+                      <a:tailEnd type="none" w="med" len="med"/>
+                    </a:lnR>
+                    <a:lnT w="12700" cap="flat" cmpd="sng" algn="ctr">
+                      <a:solidFill>
+                        <a:schemeClr val="tx1"/>
+                      </a:solidFill>
+                      <a:prstDash val="solid"/>
+                      <a:round/>
+                      <a:headEnd type="none" w="med" len="med"/>
+                      <a:tailEnd type="none" w="med" len="med"/>
+                    </a:lnT>
+                    <a:lnB w="12700" cap="flat" cmpd="sng" algn="ctr">
+                      <a:solidFill>
+                        <a:schemeClr val="tx1"/>
+                      </a:solidFill>
+                      <a:prstDash val="solid"/>
+                      <a:round/>
+                      <a:headEnd type="none" w="med" len="med"/>
+                      <a:tailEnd type="none" w="med" len="med"/>
+                    </a:lnB>
+                    <a:solidFill>
+                      <a:srgbClr val="8FAADC"/>
+                    </a:solidFill>
+                  </a:tcPr>
+                </a:tc>
+                <a:extLst>
+                  <a:ext uri="{0D108BD9-81ED-4DB2-BD59-A6C34878D82A}">
+                    <a16:rowId xmlns:a16="http://schemas.microsoft.com/office/drawing/2014/main" val="2809319250"/>
+                  </a:ext>
+                </a:extLst>
+              </a:tr>
+              <a:tr h="370840">
+                <a:tc>
+                  <a:txBody>
+                    <a:bodyPr/>
+                    <a:lstStyle/>
+                    <a:p>
+                      <a:endParaRPr lang="en-IN"/>
+                    </a:p>
+                  </a:txBody>
+                  <a:tcPr>
+                    <a:lnL w="12700" cap="flat" cmpd="sng" algn="ctr">
+                      <a:solidFill>
+                        <a:schemeClr val="tx1"/>
+                      </a:solidFill>
+                      <a:prstDash val="solid"/>
+                      <a:round/>
+                      <a:headEnd type="none" w="med" len="med"/>
+                      <a:tailEnd type="none" w="med" len="med"/>
+                    </a:lnL>
+                    <a:lnR w="12700" cap="flat" cmpd="sng" algn="ctr">
+                      <a:solidFill>
+                        <a:schemeClr val="tx1"/>
+                      </a:solidFill>
+                      <a:prstDash val="solid"/>
+                      <a:round/>
+                      <a:headEnd type="none" w="med" len="med"/>
+                      <a:tailEnd type="none" w="med" len="med"/>
+                    </a:lnR>
+                    <a:lnT w="12700" cap="flat" cmpd="sng" algn="ctr">
+                      <a:solidFill>
+                        <a:schemeClr val="tx1"/>
+                      </a:solidFill>
+                      <a:prstDash val="solid"/>
+                      <a:round/>
+                      <a:headEnd type="none" w="med" len="med"/>
+                      <a:tailEnd type="none" w="med" len="med"/>
+                    </a:lnT>
+                    <a:lnB w="12700" cap="flat" cmpd="sng" algn="ctr">
+                      <a:solidFill>
+                        <a:schemeClr val="tx1"/>
+                      </a:solidFill>
+                      <a:prstDash val="solid"/>
+                      <a:round/>
+                      <a:headEnd type="none" w="med" len="med"/>
+                      <a:tailEnd type="none" w="med" len="med"/>
+                    </a:lnB>
+                    <a:solidFill>
+                      <a:srgbClr val="8FAADC"/>
+                    </a:solidFill>
+                  </a:tcPr>
+                </a:tc>
+                <a:tc>
+                  <a:txBody>
+                    <a:bodyPr/>
+                    <a:lstStyle/>
+                    <a:p>
+                      <a:endParaRPr lang="en-IN" dirty="0"/>
+                    </a:p>
+                  </a:txBody>
+                  <a:tcPr>
+                    <a:lnL w="12700" cap="flat" cmpd="sng" algn="ctr">
+                      <a:solidFill>
+                        <a:schemeClr val="tx1"/>
+                      </a:solidFill>
+                      <a:prstDash val="solid"/>
+                      <a:round/>
+                      <a:headEnd type="none" w="med" len="med"/>
+                      <a:tailEnd type="none" w="med" len="med"/>
+                    </a:lnL>
+                    <a:lnR w="12700" cap="flat" cmpd="sng" algn="ctr">
+                      <a:solidFill>
+                        <a:schemeClr val="tx1"/>
+                      </a:solidFill>
+                      <a:prstDash val="solid"/>
+                      <a:round/>
+                      <a:headEnd type="none" w="med" len="med"/>
+                      <a:tailEnd type="none" w="med" len="med"/>
+                    </a:lnR>
+                    <a:lnT w="12700" cap="flat" cmpd="sng" algn="ctr">
+                      <a:solidFill>
+                        <a:schemeClr val="tx1"/>
+                      </a:solidFill>
+                      <a:prstDash val="solid"/>
+                      <a:round/>
+                      <a:headEnd type="none" w="med" len="med"/>
+                      <a:tailEnd type="none" w="med" len="med"/>
+                    </a:lnT>
+                    <a:lnB w="12700" cap="flat" cmpd="sng" algn="ctr">
+                      <a:solidFill>
+                        <a:schemeClr val="tx1"/>
+                      </a:solidFill>
+                      <a:prstDash val="solid"/>
+                      <a:round/>
+                      <a:headEnd type="none" w="med" len="med"/>
+                      <a:tailEnd type="none" w="med" len="med"/>
+                    </a:lnB>
+                    <a:solidFill>
+                      <a:srgbClr val="8FAADC"/>
+                    </a:solidFill>
+                  </a:tcPr>
+                </a:tc>
+                <a:tc>
+                  <a:txBody>
+                    <a:bodyPr/>
+                    <a:lstStyle/>
+                    <a:p>
+                      <a:endParaRPr lang="en-IN" dirty="0"/>
+                    </a:p>
+                  </a:txBody>
+                  <a:tcPr>
+                    <a:lnL w="12700" cap="flat" cmpd="sng" algn="ctr">
+                      <a:solidFill>
+                        <a:schemeClr val="tx1"/>
+                      </a:solidFill>
+                      <a:prstDash val="solid"/>
+                      <a:round/>
+                      <a:headEnd type="none" w="med" len="med"/>
+                      <a:tailEnd type="none" w="med" len="med"/>
+                    </a:lnL>
+                    <a:lnR w="12700" cap="flat" cmpd="sng" algn="ctr">
+                      <a:solidFill>
+                        <a:schemeClr val="tx1"/>
+                      </a:solidFill>
+                      <a:prstDash val="solid"/>
+                      <a:round/>
+                      <a:headEnd type="none" w="med" len="med"/>
+                      <a:tailEnd type="none" w="med" len="med"/>
+                    </a:lnR>
+                    <a:lnT w="12700" cap="flat" cmpd="sng" algn="ctr">
+                      <a:solidFill>
+                        <a:schemeClr val="tx1"/>
+                      </a:solidFill>
+                      <a:prstDash val="solid"/>
+                      <a:round/>
+                      <a:headEnd type="none" w="med" len="med"/>
+                      <a:tailEnd type="none" w="med" len="med"/>
+                    </a:lnT>
+                    <a:lnB w="12700" cap="flat" cmpd="sng" algn="ctr">
+                      <a:solidFill>
+                        <a:schemeClr val="tx1"/>
+                      </a:solidFill>
+                      <a:prstDash val="solid"/>
+                      <a:round/>
+                      <a:headEnd type="none" w="med" len="med"/>
+                      <a:tailEnd type="none" w="med" len="med"/>
+                    </a:lnB>
+                    <a:solidFill>
+                      <a:srgbClr val="8FAADC"/>
+                    </a:solidFill>
+                  </a:tcPr>
+                </a:tc>
+                <a:tc>
+                  <a:txBody>
+                    <a:bodyPr/>
+                    <a:lstStyle/>
+                    <a:p>
+                      <a:endParaRPr lang="en-IN"/>
+                    </a:p>
+                  </a:txBody>
+                  <a:tcPr>
+                    <a:lnL w="12700" cap="flat" cmpd="sng" algn="ctr">
+                      <a:solidFill>
+                        <a:schemeClr val="tx1"/>
+                      </a:solidFill>
+                      <a:prstDash val="solid"/>
+                      <a:round/>
+                      <a:headEnd type="none" w="med" len="med"/>
+                      <a:tailEnd type="none" w="med" len="med"/>
+                    </a:lnL>
+                    <a:lnR w="12700" cap="flat" cmpd="sng" algn="ctr">
+                      <a:solidFill>
+                        <a:schemeClr val="tx1"/>
+                      </a:solidFill>
+                      <a:prstDash val="solid"/>
+                      <a:round/>
+                      <a:headEnd type="none" w="med" len="med"/>
+                      <a:tailEnd type="none" w="med" len="med"/>
+                    </a:lnR>
+                    <a:lnT w="12700" cap="flat" cmpd="sng" algn="ctr">
+                      <a:solidFill>
+                        <a:schemeClr val="tx1"/>
+                      </a:solidFill>
+                      <a:prstDash val="solid"/>
+                      <a:round/>
+                      <a:headEnd type="none" w="med" len="med"/>
+                      <a:tailEnd type="none" w="med" len="med"/>
+                    </a:lnT>
+                    <a:lnB w="12700" cap="flat" cmpd="sng" algn="ctr">
+                      <a:solidFill>
+                        <a:schemeClr val="tx1"/>
+                      </a:solidFill>
+                      <a:prstDash val="solid"/>
+                      <a:round/>
+                      <a:headEnd type="none" w="med" len="med"/>
+                      <a:tailEnd type="none" w="med" len="med"/>
+                    </a:lnB>
+                    <a:solidFill>
+                      <a:srgbClr val="8FAADC"/>
+                    </a:solidFill>
+                  </a:tcPr>
+                </a:tc>
+                <a:extLst>
+                  <a:ext uri="{0D108BD9-81ED-4DB2-BD59-A6C34878D82A}">
+                    <a16:rowId xmlns:a16="http://schemas.microsoft.com/office/drawing/2014/main" val="1170336215"/>
+                  </a:ext>
+                </a:extLst>
+              </a:tr>
+              <a:tr h="370840">
+                <a:tc>
+                  <a:txBody>
+                    <a:bodyPr/>
+                    <a:lstStyle/>
+                    <a:p>
+                      <a:endParaRPr lang="en-IN" dirty="0"/>
+                    </a:p>
+                  </a:txBody>
+                  <a:tcPr>
+                    <a:lnL w="12700" cap="flat" cmpd="sng" algn="ctr">
+                      <a:solidFill>
+                        <a:schemeClr val="tx1"/>
+                      </a:solidFill>
+                      <a:prstDash val="solid"/>
+                      <a:round/>
+                      <a:headEnd type="none" w="med" len="med"/>
+                      <a:tailEnd type="none" w="med" len="med"/>
+                    </a:lnL>
+                    <a:lnR w="12700" cap="flat" cmpd="sng" algn="ctr">
+                      <a:solidFill>
+                        <a:schemeClr val="tx1"/>
+                      </a:solidFill>
+                      <a:prstDash val="solid"/>
+                      <a:round/>
+                      <a:headEnd type="none" w="med" len="med"/>
+                      <a:tailEnd type="none" w="med" len="med"/>
+                    </a:lnR>
+                    <a:lnT w="12700" cap="flat" cmpd="sng" algn="ctr">
+                      <a:solidFill>
+                        <a:schemeClr val="tx1"/>
+                      </a:solidFill>
+                      <a:prstDash val="solid"/>
+                      <a:round/>
+                      <a:headEnd type="none" w="med" len="med"/>
+                      <a:tailEnd type="none" w="med" len="med"/>
+                    </a:lnT>
+                    <a:lnB w="12700" cap="flat" cmpd="sng" algn="ctr">
+                      <a:solidFill>
+                        <a:schemeClr val="tx1"/>
+                      </a:solidFill>
+                      <a:prstDash val="solid"/>
+                      <a:round/>
+                      <a:headEnd type="none" w="med" len="med"/>
+                      <a:tailEnd type="none" w="med" len="med"/>
+                    </a:lnB>
+                    <a:solidFill>
+                      <a:srgbClr val="8FAADC"/>
+                    </a:solidFill>
+                  </a:tcPr>
+                </a:tc>
+                <a:tc>
+                  <a:txBody>
+                    <a:bodyPr/>
+                    <a:lstStyle/>
+                    <a:p>
+                      <a:endParaRPr lang="en-IN"/>
+                    </a:p>
+                  </a:txBody>
+                  <a:tcPr>
+                    <a:lnL w="12700" cap="flat" cmpd="sng" algn="ctr">
+                      <a:solidFill>
+                        <a:schemeClr val="tx1"/>
+                      </a:solidFill>
+                      <a:prstDash val="solid"/>
+                      <a:round/>
+                      <a:headEnd type="none" w="med" len="med"/>
+                      <a:tailEnd type="none" w="med" len="med"/>
+                    </a:lnL>
+                    <a:lnR w="12700" cap="flat" cmpd="sng" algn="ctr">
+                      <a:solidFill>
+                        <a:schemeClr val="tx1"/>
+                      </a:solidFill>
+                      <a:prstDash val="solid"/>
+                      <a:round/>
+                      <a:headEnd type="none" w="med" len="med"/>
+                      <a:tailEnd type="none" w="med" len="med"/>
+                    </a:lnR>
+                    <a:lnT w="12700" cap="flat" cmpd="sng" algn="ctr">
+                      <a:solidFill>
+                        <a:schemeClr val="tx1"/>
+                      </a:solidFill>
+                      <a:prstDash val="solid"/>
+                      <a:round/>
+                      <a:headEnd type="none" w="med" len="med"/>
+                      <a:tailEnd type="none" w="med" len="med"/>
+                    </a:lnT>
+                    <a:lnB w="12700" cap="flat" cmpd="sng" algn="ctr">
+                      <a:solidFill>
+                        <a:schemeClr val="tx1"/>
+                      </a:solidFill>
+                      <a:prstDash val="solid"/>
+                      <a:round/>
+                      <a:headEnd type="none" w="med" len="med"/>
+                      <a:tailEnd type="none" w="med" len="med"/>
+                    </a:lnB>
+                    <a:solidFill>
+                      <a:srgbClr val="8FAADC"/>
+                    </a:solidFill>
+                  </a:tcPr>
+                </a:tc>
+                <a:tc>
+                  <a:txBody>
+                    <a:bodyPr/>
+                    <a:lstStyle/>
+                    <a:p>
+                      <a:endParaRPr lang="en-IN" dirty="0"/>
+                    </a:p>
+                  </a:txBody>
+                  <a:tcPr>
+                    <a:lnL w="12700" cap="flat" cmpd="sng" algn="ctr">
+                      <a:solidFill>
+                        <a:schemeClr val="tx1"/>
+                      </a:solidFill>
+                      <a:prstDash val="solid"/>
+                      <a:round/>
+                      <a:headEnd type="none" w="med" len="med"/>
+                      <a:tailEnd type="none" w="med" len="med"/>
+                    </a:lnL>
+                    <a:lnR w="12700" cap="flat" cmpd="sng" algn="ctr">
+                      <a:solidFill>
+                        <a:schemeClr val="tx1"/>
+                      </a:solidFill>
+                      <a:prstDash val="solid"/>
+                      <a:round/>
+                      <a:headEnd type="none" w="med" len="med"/>
+                      <a:tailEnd type="none" w="med" len="med"/>
+                    </a:lnR>
+                    <a:lnT w="12700" cap="flat" cmpd="sng" algn="ctr">
+                      <a:solidFill>
+                        <a:schemeClr val="tx1"/>
+                      </a:solidFill>
+                      <a:prstDash val="solid"/>
+                      <a:round/>
+                      <a:headEnd type="none" w="med" len="med"/>
+                      <a:tailEnd type="none" w="med" len="med"/>
+                    </a:lnT>
+                    <a:lnB w="12700" cap="flat" cmpd="sng" algn="ctr">
+                      <a:solidFill>
+                        <a:schemeClr val="tx1"/>
+                      </a:solidFill>
+                      <a:prstDash val="solid"/>
+                      <a:round/>
+                      <a:headEnd type="none" w="med" len="med"/>
+                      <a:tailEnd type="none" w="med" len="med"/>
+                    </a:lnB>
+                    <a:solidFill>
+                      <a:srgbClr val="8FAADC"/>
+                    </a:solidFill>
+                  </a:tcPr>
+                </a:tc>
+                <a:tc>
+                  <a:txBody>
+                    <a:bodyPr/>
+                    <a:lstStyle/>
+                    <a:p>
+                      <a:endParaRPr lang="en-IN"/>
+                    </a:p>
+                  </a:txBody>
+                  <a:tcPr>
+                    <a:lnL w="12700" cap="flat" cmpd="sng" algn="ctr">
+                      <a:solidFill>
+                        <a:schemeClr val="tx1"/>
+                      </a:solidFill>
+                      <a:prstDash val="solid"/>
+                      <a:round/>
+                      <a:headEnd type="none" w="med" len="med"/>
+                      <a:tailEnd type="none" w="med" len="med"/>
+                    </a:lnL>
+                    <a:lnR w="12700" cap="flat" cmpd="sng" algn="ctr">
+                      <a:solidFill>
+                        <a:schemeClr val="tx1"/>
+                      </a:solidFill>
+                      <a:prstDash val="solid"/>
+                      <a:round/>
+                      <a:headEnd type="none" w="med" len="med"/>
+                      <a:tailEnd type="none" w="med" len="med"/>
+                    </a:lnR>
+                    <a:lnT w="12700" cap="flat" cmpd="sng" algn="ctr">
+                      <a:solidFill>
+                        <a:schemeClr val="tx1"/>
+                      </a:solidFill>
+                      <a:prstDash val="solid"/>
+                      <a:round/>
+                      <a:headEnd type="none" w="med" len="med"/>
+                      <a:tailEnd type="none" w="med" len="med"/>
+                    </a:lnT>
+                    <a:lnB w="12700" cap="flat" cmpd="sng" algn="ctr">
+                      <a:solidFill>
+                        <a:schemeClr val="tx1"/>
+                      </a:solidFill>
+                      <a:prstDash val="solid"/>
+                      <a:round/>
+                      <a:headEnd type="none" w="med" len="med"/>
+                      <a:tailEnd type="none" w="med" len="med"/>
+                    </a:lnB>
+                    <a:solidFill>
+                      <a:srgbClr val="8FAADC"/>
+                    </a:solidFill>
+                  </a:tcPr>
+                </a:tc>
+                <a:extLst>
+                  <a:ext uri="{0D108BD9-81ED-4DB2-BD59-A6C34878D82A}">
+                    <a16:rowId xmlns:a16="http://schemas.microsoft.com/office/drawing/2014/main" val="2363680877"/>
+                  </a:ext>
+                </a:extLst>
+              </a:tr>
+              <a:tr h="370840">
+                <a:tc>
+                  <a:txBody>
+                    <a:bodyPr/>
+                    <a:lstStyle/>
+                    <a:p>
+                      <a:endParaRPr lang="en-IN"/>
+                    </a:p>
+                  </a:txBody>
+                  <a:tcPr>
+                    <a:lnL w="12700" cap="flat" cmpd="sng" algn="ctr">
+                      <a:solidFill>
+                        <a:schemeClr val="tx1"/>
+                      </a:solidFill>
+                      <a:prstDash val="solid"/>
+                      <a:round/>
+                      <a:headEnd type="none" w="med" len="med"/>
+                      <a:tailEnd type="none" w="med" len="med"/>
+                    </a:lnL>
+                    <a:lnR w="12700" cap="flat" cmpd="sng" algn="ctr">
+                      <a:solidFill>
+                        <a:schemeClr val="tx1"/>
+                      </a:solidFill>
+                      <a:prstDash val="solid"/>
+                      <a:round/>
+                      <a:headEnd type="none" w="med" len="med"/>
+                      <a:tailEnd type="none" w="med" len="med"/>
+                    </a:lnR>
+                    <a:lnT w="12700" cap="flat" cmpd="sng" algn="ctr">
+                      <a:solidFill>
+                        <a:schemeClr val="tx1"/>
+                      </a:solidFill>
+                      <a:prstDash val="solid"/>
+                      <a:round/>
+                      <a:headEnd type="none" w="med" len="med"/>
+                      <a:tailEnd type="none" w="med" len="med"/>
+                    </a:lnT>
+                    <a:lnB w="12700" cap="flat" cmpd="sng" algn="ctr">
+                      <a:solidFill>
+                        <a:schemeClr val="tx1"/>
+                      </a:solidFill>
+                      <a:prstDash val="solid"/>
+                      <a:round/>
+                      <a:headEnd type="none" w="med" len="med"/>
+                      <a:tailEnd type="none" w="med" len="med"/>
+                    </a:lnB>
+                    <a:solidFill>
+                      <a:srgbClr val="8FAADC"/>
+                    </a:solidFill>
+                  </a:tcPr>
+                </a:tc>
+                <a:tc>
+                  <a:txBody>
+                    <a:bodyPr/>
+                    <a:lstStyle/>
+                    <a:p>
+                      <a:endParaRPr lang="en-IN"/>
+                    </a:p>
+                  </a:txBody>
+                  <a:tcPr>
+                    <a:lnL w="12700" cap="flat" cmpd="sng" algn="ctr">
+                      <a:solidFill>
+                        <a:schemeClr val="tx1"/>
+                      </a:solidFill>
+                      <a:prstDash val="solid"/>
+                      <a:round/>
+                      <a:headEnd type="none" w="med" len="med"/>
+                      <a:tailEnd type="none" w="med" len="med"/>
+                    </a:lnL>
+                    <a:lnR w="12700" cap="flat" cmpd="sng" algn="ctr">
+                      <a:solidFill>
+                        <a:schemeClr val="tx1"/>
+                      </a:solidFill>
+                      <a:prstDash val="solid"/>
+                      <a:round/>
+                      <a:headEnd type="none" w="med" len="med"/>
+                      <a:tailEnd type="none" w="med" len="med"/>
+                    </a:lnR>
+                    <a:lnT w="12700" cap="flat" cmpd="sng" algn="ctr">
+                      <a:solidFill>
+                        <a:schemeClr val="tx1"/>
+                      </a:solidFill>
+                      <a:prstDash val="solid"/>
+                      <a:round/>
+                      <a:headEnd type="none" w="med" len="med"/>
+                      <a:tailEnd type="none" w="med" len="med"/>
+                    </a:lnT>
+                    <a:lnB w="12700" cap="flat" cmpd="sng" algn="ctr">
+                      <a:solidFill>
+                        <a:schemeClr val="tx1"/>
+                      </a:solidFill>
+                      <a:prstDash val="solid"/>
+                      <a:round/>
+                      <a:headEnd type="none" w="med" len="med"/>
+                      <a:tailEnd type="none" w="med" len="med"/>
+                    </a:lnB>
+                    <a:solidFill>
+                      <a:srgbClr val="8FAADC"/>
+                    </a:solidFill>
+                  </a:tcPr>
+                </a:tc>
+                <a:tc>
+                  <a:txBody>
+                    <a:bodyPr/>
+                    <a:lstStyle/>
+                    <a:p>
+                      <a:endParaRPr lang="en-IN" dirty="0"/>
+                    </a:p>
+                  </a:txBody>
+                  <a:tcPr>
+                    <a:lnL w="12700" cap="flat" cmpd="sng" algn="ctr">
+                      <a:solidFill>
+                        <a:schemeClr val="tx1"/>
+                      </a:solidFill>
+                      <a:prstDash val="solid"/>
+                      <a:round/>
+                      <a:headEnd type="none" w="med" len="med"/>
+                      <a:tailEnd type="none" w="med" len="med"/>
+                    </a:lnL>
+                    <a:lnR w="12700" cap="flat" cmpd="sng" algn="ctr">
+                      <a:solidFill>
+                        <a:schemeClr val="tx1"/>
+                      </a:solidFill>
+                      <a:prstDash val="solid"/>
+                      <a:round/>
+                      <a:headEnd type="none" w="med" len="med"/>
+                      <a:tailEnd type="none" w="med" len="med"/>
+                    </a:lnR>
+                    <a:lnT w="12700" cap="flat" cmpd="sng" algn="ctr">
+                      <a:solidFill>
+                        <a:schemeClr val="tx1"/>
+                      </a:solidFill>
+                      <a:prstDash val="solid"/>
+                      <a:round/>
+                      <a:headEnd type="none" w="med" len="med"/>
+                      <a:tailEnd type="none" w="med" len="med"/>
+                    </a:lnT>
+                    <a:lnB w="12700" cap="flat" cmpd="sng" algn="ctr">
+                      <a:solidFill>
+                        <a:schemeClr val="tx1"/>
+                      </a:solidFill>
+                      <a:prstDash val="solid"/>
+                      <a:round/>
+                      <a:headEnd type="none" w="med" len="med"/>
+                      <a:tailEnd type="none" w="med" len="med"/>
+                    </a:lnB>
+                    <a:solidFill>
+                      <a:srgbClr val="8FAADC"/>
+                    </a:solidFill>
+                  </a:tcPr>
+                </a:tc>
+                <a:tc>
+                  <a:txBody>
+                    <a:bodyPr/>
+                    <a:lstStyle/>
+                    <a:p>
+                      <a:endParaRPr lang="en-IN" dirty="0"/>
+                    </a:p>
+                  </a:txBody>
+                  <a:tcPr>
+                    <a:lnL w="12700" cap="flat" cmpd="sng" algn="ctr">
+                      <a:solidFill>
+                        <a:schemeClr val="tx1"/>
+                      </a:solidFill>
+                      <a:prstDash val="solid"/>
+                      <a:round/>
+                      <a:headEnd type="none" w="med" len="med"/>
+                      <a:tailEnd type="none" w="med" len="med"/>
+                    </a:lnL>
+                    <a:lnR w="12700" cap="flat" cmpd="sng" algn="ctr">
+                      <a:solidFill>
+                        <a:schemeClr val="tx1"/>
+                      </a:solidFill>
+                      <a:prstDash val="solid"/>
+                      <a:round/>
+                      <a:headEnd type="none" w="med" len="med"/>
+                      <a:tailEnd type="none" w="med" len="med"/>
+                    </a:lnR>
+                    <a:lnT w="12700" cap="flat" cmpd="sng" algn="ctr">
+                      <a:solidFill>
+                        <a:schemeClr val="tx1"/>
+                      </a:solidFill>
+                      <a:prstDash val="solid"/>
+                      <a:round/>
+                      <a:headEnd type="none" w="med" len="med"/>
+                      <a:tailEnd type="none" w="med" len="med"/>
+                    </a:lnT>
+                    <a:lnB w="12700" cap="flat" cmpd="sng" algn="ctr">
+                      <a:solidFill>
+                        <a:schemeClr val="tx1"/>
+                      </a:solidFill>
+                      <a:prstDash val="solid"/>
+                      <a:round/>
+                      <a:headEnd type="none" w="med" len="med"/>
+                      <a:tailEnd type="none" w="med" len="med"/>
+                    </a:lnB>
+                    <a:solidFill>
+                      <a:srgbClr val="8FAADC"/>
+                    </a:solidFill>
+                  </a:tcPr>
+                </a:tc>
+                <a:extLst>
+                  <a:ext uri="{0D108BD9-81ED-4DB2-BD59-A6C34878D82A}">
+                    <a16:rowId xmlns:a16="http://schemas.microsoft.com/office/drawing/2014/main" val="2031315940"/>
+                  </a:ext>
+                </a:extLst>
+              </a:tr>
+              <a:tr h="370840">
+                <a:tc>
+                  <a:txBody>
+                    <a:bodyPr/>
+                    <a:lstStyle/>
+                    <a:p>
+                      <a:endParaRPr lang="en-IN"/>
+                    </a:p>
+                  </a:txBody>
+                  <a:tcPr>
+                    <a:lnL w="12700" cap="flat" cmpd="sng" algn="ctr">
+                      <a:solidFill>
+                        <a:schemeClr val="tx1"/>
+                      </a:solidFill>
+                      <a:prstDash val="solid"/>
+                      <a:round/>
+                      <a:headEnd type="none" w="med" len="med"/>
+                      <a:tailEnd type="none" w="med" len="med"/>
+                    </a:lnL>
+                    <a:lnR w="12700" cap="flat" cmpd="sng" algn="ctr">
+                      <a:solidFill>
+                        <a:schemeClr val="tx1"/>
+                      </a:solidFill>
+                      <a:prstDash val="solid"/>
+                      <a:round/>
+                      <a:headEnd type="none" w="med" len="med"/>
+                      <a:tailEnd type="none" w="med" len="med"/>
+                    </a:lnR>
+                    <a:lnT w="12700" cap="flat" cmpd="sng" algn="ctr">
+                      <a:solidFill>
+                        <a:schemeClr val="tx1"/>
+                      </a:solidFill>
+                      <a:prstDash val="solid"/>
+                      <a:round/>
+                      <a:headEnd type="none" w="med" len="med"/>
+                      <a:tailEnd type="none" w="med" len="med"/>
+                    </a:lnT>
+                    <a:lnB w="12700" cap="flat" cmpd="sng" algn="ctr">
+                      <a:solidFill>
+                        <a:schemeClr val="tx1"/>
+                      </a:solidFill>
+                      <a:prstDash val="solid"/>
+                      <a:round/>
+                      <a:headEnd type="none" w="med" len="med"/>
+                      <a:tailEnd type="none" w="med" len="med"/>
+                    </a:lnB>
+                    <a:solidFill>
+                      <a:srgbClr val="8FAADC"/>
+                    </a:solidFill>
+                  </a:tcPr>
+                </a:tc>
+                <a:tc>
+                  <a:txBody>
+                    <a:bodyPr/>
+                    <a:lstStyle/>
+                    <a:p>
+                      <a:endParaRPr lang="en-IN"/>
+                    </a:p>
+                  </a:txBody>
+                  <a:tcPr>
+                    <a:lnL w="12700" cap="flat" cmpd="sng" algn="ctr">
+                      <a:solidFill>
+                        <a:schemeClr val="tx1"/>
+                      </a:solidFill>
+                      <a:prstDash val="solid"/>
+                      <a:round/>
+                      <a:headEnd type="none" w="med" len="med"/>
+                      <a:tailEnd type="none" w="med" len="med"/>
+                    </a:lnL>
+                    <a:lnR w="12700" cap="flat" cmpd="sng" algn="ctr">
+                      <a:solidFill>
+                        <a:schemeClr val="tx1"/>
+                      </a:solidFill>
+                      <a:prstDash val="solid"/>
+                      <a:round/>
+                      <a:headEnd type="none" w="med" len="med"/>
+                      <a:tailEnd type="none" w="med" len="med"/>
+                    </a:lnR>
+                    <a:lnT w="12700" cap="flat" cmpd="sng" algn="ctr">
+                      <a:solidFill>
+                        <a:schemeClr val="tx1"/>
+                      </a:solidFill>
+                      <a:prstDash val="solid"/>
+                      <a:round/>
+                      <a:headEnd type="none" w="med" len="med"/>
+                      <a:tailEnd type="none" w="med" len="med"/>
+                    </a:lnT>
+                    <a:lnB w="12700" cap="flat" cmpd="sng" algn="ctr">
+                      <a:solidFill>
+                        <a:schemeClr val="tx1"/>
+                      </a:solidFill>
+                      <a:prstDash val="solid"/>
+                      <a:round/>
+                      <a:headEnd type="none" w="med" len="med"/>
+                      <a:tailEnd type="none" w="med" len="med"/>
+                    </a:lnB>
+                    <a:solidFill>
+                      <a:srgbClr val="8FAADC"/>
+                    </a:solidFill>
+                  </a:tcPr>
+                </a:tc>
+                <a:tc>
+                  <a:txBody>
+                    <a:bodyPr/>
+                    <a:lstStyle/>
+                    <a:p>
+                      <a:endParaRPr lang="en-IN"/>
+                    </a:p>
+                  </a:txBody>
+                  <a:tcPr>
+                    <a:lnL w="12700" cap="flat" cmpd="sng" algn="ctr">
+                      <a:solidFill>
+                        <a:schemeClr val="tx1"/>
+                      </a:solidFill>
+                      <a:prstDash val="solid"/>
+                      <a:round/>
+                      <a:headEnd type="none" w="med" len="med"/>
+                      <a:tailEnd type="none" w="med" len="med"/>
+                    </a:lnL>
+                    <a:lnR w="12700" cap="flat" cmpd="sng" algn="ctr">
+                      <a:solidFill>
+                        <a:schemeClr val="tx1"/>
+                      </a:solidFill>
+                      <a:prstDash val="solid"/>
+                      <a:round/>
+                      <a:headEnd type="none" w="med" len="med"/>
+                      <a:tailEnd type="none" w="med" len="med"/>
+                    </a:lnR>
+                    <a:lnT w="12700" cap="flat" cmpd="sng" algn="ctr">
+                      <a:solidFill>
+                        <a:schemeClr val="tx1"/>
+                      </a:solidFill>
+                      <a:prstDash val="solid"/>
+                      <a:round/>
+                      <a:headEnd type="none" w="med" len="med"/>
+                      <a:tailEnd type="none" w="med" len="med"/>
+                    </a:lnT>
+                    <a:lnB w="12700" cap="flat" cmpd="sng" algn="ctr">
+                      <a:solidFill>
+                        <a:schemeClr val="tx1"/>
+                      </a:solidFill>
+                      <a:prstDash val="solid"/>
+                      <a:round/>
+                      <a:headEnd type="none" w="med" len="med"/>
+                      <a:tailEnd type="none" w="med" len="med"/>
+                    </a:lnB>
+                    <a:solidFill>
+                      <a:srgbClr val="8FAADC"/>
+                    </a:solidFill>
+                  </a:tcPr>
+                </a:tc>
+                <a:tc>
+                  <a:txBody>
+                    <a:bodyPr/>
+                    <a:lstStyle/>
+                    <a:p>
+                      <a:endParaRPr lang="en-IN" dirty="0"/>
+                    </a:p>
+                  </a:txBody>
+                  <a:tcPr>
+                    <a:lnL w="12700" cap="flat" cmpd="sng" algn="ctr">
+                      <a:solidFill>
+                        <a:schemeClr val="tx1"/>
+                      </a:solidFill>
+                      <a:prstDash val="solid"/>
+                      <a:round/>
+                      <a:headEnd type="none" w="med" len="med"/>
+                      <a:tailEnd type="none" w="med" len="med"/>
+                    </a:lnL>
+                    <a:lnR w="12700" cap="flat" cmpd="sng" algn="ctr">
+                      <a:solidFill>
+                        <a:schemeClr val="tx1"/>
+                      </a:solidFill>
+                      <a:prstDash val="solid"/>
+                      <a:round/>
+                      <a:headEnd type="none" w="med" len="med"/>
+                      <a:tailEnd type="none" w="med" len="med"/>
+                    </a:lnR>
+                    <a:lnT w="12700" cap="flat" cmpd="sng" algn="ctr">
+                      <a:solidFill>
+                        <a:schemeClr val="tx1"/>
+                      </a:solidFill>
+                      <a:prstDash val="solid"/>
+                      <a:round/>
+                      <a:headEnd type="none" w="med" len="med"/>
+                      <a:tailEnd type="none" w="med" len="med"/>
+                    </a:lnT>
+                    <a:lnB w="12700" cap="flat" cmpd="sng" algn="ctr">
+                      <a:solidFill>
+                        <a:schemeClr val="tx1"/>
+                      </a:solidFill>
+                      <a:prstDash val="solid"/>
+                      <a:round/>
+                      <a:headEnd type="none" w="med" len="med"/>
+                      <a:tailEnd type="none" w="med" len="med"/>
+                    </a:lnB>
+                    <a:solidFill>
+                      <a:srgbClr val="8FAADC"/>
+                    </a:solidFill>
+                  </a:tcPr>
+                </a:tc>
+                <a:extLst>
+                  <a:ext uri="{0D108BD9-81ED-4DB2-BD59-A6C34878D82A}">
+                    <a16:rowId xmlns:a16="http://schemas.microsoft.com/office/drawing/2014/main" val="992374018"/>
+                  </a:ext>
+                </a:extLst>
+              </a:tr>
+            </a:tbl>
+          </a:graphicData>
+        </a:graphic>
+      </p:graphicFrame>
     </p:spTree>
     <p:extLst>
       <p:ext uri="{BB962C8B-B14F-4D97-AF65-F5344CB8AC3E}">
-        <p14:creationId xmlns:p14="http://schemas.microsoft.com/office/powerpoint/2010/main" val="3081722400"/>
+        <p14:creationId xmlns:p14="http://schemas.microsoft.com/office/powerpoint/2010/main" val="2150309207"/>
       </p:ext>
     </p:extLst>
   </p:cSld>

</xml_diff>

<commit_message>
pushing for claude context, attendance page not finished
</commit_message>
<xml_diff>
--- a/documentation/Frontend mockup.pptx
+++ b/documentation/Frontend mockup.pptx
@@ -278,7 +278,7 @@
           <a:p>
             <a:fld id="{005069A1-986F-417B-B4C2-5BD1BF3375D4}" type="datetimeFigureOut">
               <a:rPr lang="en-IN" smtClean="0"/>
-              <a:t>11-06-2026</a:t>
+              <a:t>13-06-2026</a:t>
             </a:fld>
             <a:endParaRPr lang="en-IN"/>
           </a:p>
@@ -478,7 +478,7 @@
           <a:p>
             <a:fld id="{005069A1-986F-417B-B4C2-5BD1BF3375D4}" type="datetimeFigureOut">
               <a:rPr lang="en-IN" smtClean="0"/>
-              <a:t>11-06-2026</a:t>
+              <a:t>13-06-2026</a:t>
             </a:fld>
             <a:endParaRPr lang="en-IN"/>
           </a:p>
@@ -688,7 +688,7 @@
           <a:p>
             <a:fld id="{005069A1-986F-417B-B4C2-5BD1BF3375D4}" type="datetimeFigureOut">
               <a:rPr lang="en-IN" smtClean="0"/>
-              <a:t>11-06-2026</a:t>
+              <a:t>13-06-2026</a:t>
             </a:fld>
             <a:endParaRPr lang="en-IN"/>
           </a:p>
@@ -888,7 +888,7 @@
           <a:p>
             <a:fld id="{005069A1-986F-417B-B4C2-5BD1BF3375D4}" type="datetimeFigureOut">
               <a:rPr lang="en-IN" smtClean="0"/>
-              <a:t>11-06-2026</a:t>
+              <a:t>13-06-2026</a:t>
             </a:fld>
             <a:endParaRPr lang="en-IN"/>
           </a:p>
@@ -1164,7 +1164,7 @@
           <a:p>
             <a:fld id="{005069A1-986F-417B-B4C2-5BD1BF3375D4}" type="datetimeFigureOut">
               <a:rPr lang="en-IN" smtClean="0"/>
-              <a:t>11-06-2026</a:t>
+              <a:t>13-06-2026</a:t>
             </a:fld>
             <a:endParaRPr lang="en-IN"/>
           </a:p>
@@ -1432,7 +1432,7 @@
           <a:p>
             <a:fld id="{005069A1-986F-417B-B4C2-5BD1BF3375D4}" type="datetimeFigureOut">
               <a:rPr lang="en-IN" smtClean="0"/>
-              <a:t>11-06-2026</a:t>
+              <a:t>13-06-2026</a:t>
             </a:fld>
             <a:endParaRPr lang="en-IN"/>
           </a:p>
@@ -1847,7 +1847,7 @@
           <a:p>
             <a:fld id="{005069A1-986F-417B-B4C2-5BD1BF3375D4}" type="datetimeFigureOut">
               <a:rPr lang="en-IN" smtClean="0"/>
-              <a:t>11-06-2026</a:t>
+              <a:t>13-06-2026</a:t>
             </a:fld>
             <a:endParaRPr lang="en-IN"/>
           </a:p>
@@ -1989,7 +1989,7 @@
           <a:p>
             <a:fld id="{005069A1-986F-417B-B4C2-5BD1BF3375D4}" type="datetimeFigureOut">
               <a:rPr lang="en-IN" smtClean="0"/>
-              <a:t>11-06-2026</a:t>
+              <a:t>13-06-2026</a:t>
             </a:fld>
             <a:endParaRPr lang="en-IN"/>
           </a:p>
@@ -2102,7 +2102,7 @@
           <a:p>
             <a:fld id="{005069A1-986F-417B-B4C2-5BD1BF3375D4}" type="datetimeFigureOut">
               <a:rPr lang="en-IN" smtClean="0"/>
-              <a:t>11-06-2026</a:t>
+              <a:t>13-06-2026</a:t>
             </a:fld>
             <a:endParaRPr lang="en-IN"/>
           </a:p>
@@ -2415,7 +2415,7 @@
           <a:p>
             <a:fld id="{005069A1-986F-417B-B4C2-5BD1BF3375D4}" type="datetimeFigureOut">
               <a:rPr lang="en-IN" smtClean="0"/>
-              <a:t>11-06-2026</a:t>
+              <a:t>13-06-2026</a:t>
             </a:fld>
             <a:endParaRPr lang="en-IN"/>
           </a:p>
@@ -2704,7 +2704,7 @@
           <a:p>
             <a:fld id="{005069A1-986F-417B-B4C2-5BD1BF3375D4}" type="datetimeFigureOut">
               <a:rPr lang="en-IN" smtClean="0"/>
-              <a:t>11-06-2026</a:t>
+              <a:t>13-06-2026</a:t>
             </a:fld>
             <a:endParaRPr lang="en-IN"/>
           </a:p>
@@ -2947,7 +2947,7 @@
           <a:p>
             <a:fld id="{005069A1-986F-417B-B4C2-5BD1BF3375D4}" type="datetimeFigureOut">
               <a:rPr lang="en-IN" smtClean="0"/>
-              <a:t>11-06-2026</a:t>
+              <a:t>13-06-2026</a:t>
             </a:fld>
             <a:endParaRPr lang="en-IN"/>
           </a:p>
@@ -15132,6 +15132,56 @@
           </a:p>
         </p:txBody>
       </p:sp>
+      <p:sp>
+        <p:nvSpPr>
+          <p:cNvPr id="17" name="Rectangle: Rounded Corners 16">
+            <a:extLst>
+              <a:ext uri="{FF2B5EF4-FFF2-40B4-BE49-F238E27FC236}">
+                <a16:creationId xmlns:a16="http://schemas.microsoft.com/office/drawing/2014/main" id="{BB8E9C1C-933F-D4B9-7B6D-C41077BC6B07}"/>
+              </a:ext>
+            </a:extLst>
+          </p:cNvPr>
+          <p:cNvSpPr/>
+          <p:nvPr/>
+        </p:nvSpPr>
+        <p:spPr>
+          <a:xfrm>
+            <a:off x="10588479" y="6109944"/>
+            <a:ext cx="1301262" cy="370840"/>
+          </a:xfrm>
+          <a:prstGeom prst="roundRect">
+            <a:avLst/>
+          </a:prstGeom>
+        </p:spPr>
+        <p:style>
+          <a:lnRef idx="2">
+            <a:schemeClr val="accent1">
+              <a:shade val="15000"/>
+            </a:schemeClr>
+          </a:lnRef>
+          <a:fillRef idx="1">
+            <a:schemeClr val="accent1"/>
+          </a:fillRef>
+          <a:effectRef idx="0">
+            <a:schemeClr val="accent1"/>
+          </a:effectRef>
+          <a:fontRef idx="minor">
+            <a:schemeClr val="lt1"/>
+          </a:fontRef>
+        </p:style>
+        <p:txBody>
+          <a:bodyPr rtlCol="0" anchor="ctr"/>
+          <a:lstStyle/>
+          <a:p>
+            <a:pPr algn="ctr"/>
+            <a:r>
+              <a:rPr lang="en-US" dirty="0"/>
+              <a:t>Export</a:t>
+            </a:r>
+            <a:endParaRPr lang="en-IN" dirty="0"/>
+          </a:p>
+        </p:txBody>
+      </p:sp>
     </p:spTree>
     <p:extLst>
       <p:ext uri="{BB962C8B-B14F-4D97-AF65-F5344CB8AC3E}">

</xml_diff>